<commit_message>
12-slide final: + System Architecture & Design slide
</commit_message>
<xml_diff>
--- a/CylDist_Platform_Presentation.pptx
+++ b/CylDist_Platform_Presentation.pptx
@@ -2,7 +2,7 @@
 <file path=ppt/presentation.xml><?xml version="1.0" encoding="utf-8"?>
 <p:presentation xmlns:a="http://schemas.openxmlformats.org/drawingml/2006/main" xmlns:r="http://schemas.openxmlformats.org/officeDocument/2006/relationships" xmlns:p="http://schemas.openxmlformats.org/presentationml/2006/main">
   <p:sldMasterIdLst>
-    <p:sldMasterId id="2147483648" r:id="rId12"/>
+    <p:sldMasterId id="2147483648" r:id="rId13"/>
   </p:sldMasterIdLst>
   <p:sldIdLst>
     <p:sldId id="256" r:id="rId1"/>
@@ -16,6 +16,7 @@
     <p:sldId id="264" r:id="rId9"/>
     <p:sldId id="265" r:id="rId10"/>
     <p:sldId id="266" r:id="rId11"/>
+    <p:sldId id="267" r:id="rId12"/>
   </p:sldIdLst>
   <p:sldSz cx="12192000" cy="6858000" type="screen16x9"/>
   <p:notesSz cx="6858000" cy="12192000"/>
@@ -6518,6 +6519,3255 @@
 </p:sld>
 </file>
 
+<file path=ppt/slides/slide12.xml><?xml version="1.0" encoding="utf-8"?>
+<p:sld xmlns:a="http://schemas.openxmlformats.org/drawingml/2006/main" xmlns:r="http://schemas.openxmlformats.org/officeDocument/2006/relationships" xmlns:p="http://schemas.openxmlformats.org/presentationml/2006/main">
+  <p:cSld>
+    <p:spTree>
+      <p:nvGrpSpPr>
+        <p:cNvPr id="1" name=""/>
+        <p:cNvGrpSpPr/>
+        <p:nvPr/>
+      </p:nvGrpSpPr>
+      <p:grpSpPr>
+        <a:xfrm>
+          <a:off x="0" y="0"/>
+          <a:ext cx="0" cy="0"/>
+          <a:chOff x="0" y="0"/>
+          <a:chExt cx="0" cy="0"/>
+        </a:xfrm>
+      </p:grpSpPr>
+      <p:sp>
+        <p:nvSpPr>
+          <p:cNvPr id="966" name="r"/>
+          <p:cNvSpPr/>
+          <p:nvPr/>
+        </p:nvSpPr>
+        <p:spPr>
+          <a:xfrm>
+            <a:off x="0" y="0"/>
+            <a:ext cx="12192000" cy="6858000"/>
+          </a:xfrm>
+          <a:prstGeom prst="rect">
+            <a:avLst/>
+          </a:prstGeom>
+          <a:solidFill>
+            <a:srgbClr val="F8FAFC"/>
+          </a:solidFill>
+          <a:ln>
+            <a:noFill/>
+          </a:ln>
+        </p:spPr>
+        <p:txBody>
+          <a:bodyPr/>
+          <a:lstStyle/>
+          <a:p/>
+        </p:txBody>
+      </p:sp>
+      <p:sp>
+        <p:nvSpPr>
+          <p:cNvPr id="967" name="r"/>
+          <p:cNvSpPr/>
+          <p:nvPr/>
+        </p:nvSpPr>
+        <p:spPr>
+          <a:xfrm>
+            <a:off x="0" y="0"/>
+            <a:ext cx="12192000" cy="868680"/>
+          </a:xfrm>
+          <a:prstGeom prst="rect">
+            <a:avLst/>
+          </a:prstGeom>
+          <a:solidFill>
+            <a:srgbClr val="0B1739"/>
+          </a:solidFill>
+          <a:ln>
+            <a:noFill/>
+          </a:ln>
+        </p:spPr>
+        <p:txBody>
+          <a:bodyPr/>
+          <a:lstStyle/>
+          <a:p/>
+        </p:txBody>
+      </p:sp>
+      <p:sp>
+        <p:nvSpPr>
+          <p:cNvPr id="968" name="r"/>
+          <p:cNvSpPr/>
+          <p:nvPr/>
+        </p:nvSpPr>
+        <p:spPr>
+          <a:xfrm>
+            <a:off x="0" y="868680"/>
+            <a:ext cx="12192000" cy="36576"/>
+          </a:xfrm>
+          <a:prstGeom prst="rect">
+            <a:avLst/>
+          </a:prstGeom>
+          <a:solidFill>
+            <a:srgbClr val="F97316"/>
+          </a:solidFill>
+          <a:ln>
+            <a:noFill/>
+          </a:ln>
+        </p:spPr>
+        <p:txBody>
+          <a:bodyPr/>
+          <a:lstStyle/>
+          <a:p/>
+        </p:txBody>
+      </p:sp>
+      <p:sp>
+        <p:nvSpPr>
+          <p:cNvPr id="969" name="t"/>
+          <p:cNvSpPr txBox="1"/>
+          <p:nvPr/>
+        </p:nvSpPr>
+        <p:spPr>
+          <a:xfrm>
+            <a:off x="365760" y="164592"/>
+            <a:ext cx="1828800" cy="640080"/>
+          </a:xfrm>
+          <a:prstGeom prst="rect">
+            <a:avLst/>
+          </a:prstGeom>
+          <a:noFill/>
+        </p:spPr>
+        <p:txBody>
+          <a:bodyPr wrap="square" anchor="t" rtlCol="0"/>
+          <a:lstStyle/>
+          <a:p>
+            <a:pPr algn="l">
+              <a:buNone/>
+            </a:pPr>
+            <a:r>
+              <a:rPr lang="en-US" sz="3600" b="1" dirty="0">
+                <a:solidFill>
+                  <a:srgbClr val="F97316"/>
+                </a:solidFill>
+                <a:latin typeface="Calibri"/>
+              </a:rPr>
+              <a:t>12</a:t>
+            </a:r>
+          </a:p>
+        </p:txBody>
+      </p:sp>
+      <p:sp>
+        <p:nvSpPr>
+          <p:cNvPr id="970" name="t"/>
+          <p:cNvSpPr txBox="1"/>
+          <p:nvPr/>
+        </p:nvSpPr>
+        <p:spPr>
+          <a:xfrm>
+            <a:off x="1188720" y="164592"/>
+            <a:ext cx="10058400" cy="292608"/>
+          </a:xfrm>
+          <a:prstGeom prst="rect">
+            <a:avLst/>
+          </a:prstGeom>
+          <a:noFill/>
+        </p:spPr>
+        <p:txBody>
+          <a:bodyPr wrap="square" anchor="t" rtlCol="0"/>
+          <a:lstStyle/>
+          <a:p>
+            <a:pPr algn="l">
+              <a:buNone/>
+            </a:pPr>
+            <a:r>
+              <a:rPr lang="en-US" sz="1000" b="1" dirty="0">
+                <a:solidFill>
+                  <a:srgbClr val="FBBF24"/>
+                </a:solidFill>
+                <a:latin typeface="Calibri"/>
+              </a:rPr>
+              <a:t>DEEP DIVE  |  PLATFORM ARCHITECTURE</a:t>
+            </a:r>
+          </a:p>
+        </p:txBody>
+      </p:sp>
+      <p:sp>
+        <p:nvSpPr>
+          <p:cNvPr id="971" name="t"/>
+          <p:cNvSpPr txBox="1"/>
+          <p:nvPr/>
+        </p:nvSpPr>
+        <p:spPr>
+          <a:xfrm>
+            <a:off x="1188720" y="457200"/>
+            <a:ext cx="10515600" cy="411480"/>
+          </a:xfrm>
+          <a:prstGeom prst="rect">
+            <a:avLst/>
+          </a:prstGeom>
+          <a:noFill/>
+        </p:spPr>
+        <p:txBody>
+          <a:bodyPr wrap="square" anchor="t" rtlCol="0"/>
+          <a:lstStyle/>
+          <a:p>
+            <a:pPr algn="l">
+              <a:buNone/>
+            </a:pPr>
+            <a:r>
+              <a:rPr lang="en-US" sz="1700" b="1" dirty="0">
+                <a:solidFill>
+                  <a:srgbClr val="FFFFFF"/>
+                </a:solidFill>
+                <a:latin typeface="Calibri"/>
+              </a:rPr>
+              <a:t>System Architecture &amp; Design</a:t>
+            </a:r>
+          </a:p>
+        </p:txBody>
+      </p:sp>
+      <p:sp>
+        <p:nvSpPr>
+          <p:cNvPr id="972" name="t"/>
+          <p:cNvSpPr txBox="1"/>
+          <p:nvPr/>
+        </p:nvSpPr>
+        <p:spPr>
+          <a:xfrm>
+            <a:off x="457200" y="960120"/>
+            <a:ext cx="11430000" cy="274320"/>
+          </a:xfrm>
+          <a:prstGeom prst="rect">
+            <a:avLst/>
+          </a:prstGeom>
+          <a:noFill/>
+        </p:spPr>
+        <p:txBody>
+          <a:bodyPr wrap="square" anchor="t" rtlCol="0"/>
+          <a:lstStyle/>
+          <a:p>
+            <a:pPr algn="l">
+              <a:buNone/>
+            </a:pPr>
+            <a:r>
+              <a:rPr lang="en-US" sz="1000" dirty="0">
+                <a:solidFill>
+                  <a:srgbClr val="475569"/>
+                </a:solidFill>
+                <a:latin typeface="Calibri"/>
+              </a:rPr>
+              <a:t>Three-tier architecture:  Client Layer  -&gt;  API Gateway  -&gt;  Data + External Services</a:t>
+            </a:r>
+          </a:p>
+        </p:txBody>
+      </p:sp>
+      <p:sp>
+        <p:nvSpPr>
+          <p:cNvPr id="973" name="s"/>
+          <p:cNvSpPr/>
+          <p:nvPr/>
+        </p:nvSpPr>
+        <p:spPr>
+          <a:xfrm>
+            <a:off x="365760" y="1280160"/>
+            <a:ext cx="11430000" cy="914400"/>
+          </a:xfrm>
+          <a:prstGeom prst="roundRect">
+            <a:avLst>
+              <a:gd name="adj" fmla="val 8000"/>
+            </a:avLst>
+          </a:prstGeom>
+          <a:solidFill>
+            <a:srgbClr val="FFFFFF"/>
+          </a:solidFill>
+          <a:ln>
+            <a:noFill/>
+          </a:ln>
+          <a:effectLst>
+            <a:outerShdw blurRad="50800" dist="38100" dir="2700000" rotWithShape="0">
+              <a:srgbClr val="000000">
+                <a:alpha val="35000"/>
+              </a:srgbClr>
+            </a:outerShdw>
+          </a:effectLst>
+        </p:spPr>
+        <p:txBody>
+          <a:bodyPr wrap="square" anchor="ctr" rtlCol="0" lIns="91440" tIns="91440" rIns="91440" bIns="91440"/>
+          <a:lstStyle/>
+          <a:p/>
+        </p:txBody>
+      </p:sp>
+      <p:sp>
+        <p:nvSpPr>
+          <p:cNvPr id="974" name="r"/>
+          <p:cNvSpPr/>
+          <p:nvPr/>
+        </p:nvSpPr>
+        <p:spPr>
+          <a:xfrm>
+            <a:off x="365760" y="1280160"/>
+            <a:ext cx="11430000" cy="54864"/>
+          </a:xfrm>
+          <a:prstGeom prst="rect">
+            <a:avLst/>
+          </a:prstGeom>
+          <a:solidFill>
+            <a:srgbClr val="3B82F6"/>
+          </a:solidFill>
+          <a:ln>
+            <a:noFill/>
+          </a:ln>
+        </p:spPr>
+        <p:txBody>
+          <a:bodyPr/>
+          <a:lstStyle/>
+          <a:p/>
+        </p:txBody>
+      </p:sp>
+      <p:sp>
+        <p:nvSpPr>
+          <p:cNvPr id="975" name="t"/>
+          <p:cNvSpPr txBox="1"/>
+          <p:nvPr/>
+        </p:nvSpPr>
+        <p:spPr>
+          <a:xfrm>
+            <a:off x="548640" y="1353312"/>
+            <a:ext cx="6400800" cy="274320"/>
+          </a:xfrm>
+          <a:prstGeom prst="rect">
+            <a:avLst/>
+          </a:prstGeom>
+          <a:noFill/>
+        </p:spPr>
+        <p:txBody>
+          <a:bodyPr wrap="square" anchor="t" rtlCol="0"/>
+          <a:lstStyle/>
+          <a:p>
+            <a:pPr algn="l">
+              <a:buNone/>
+            </a:pPr>
+            <a:r>
+              <a:rPr lang="en-US" sz="1000" b="1" dirty="0">
+                <a:solidFill>
+                  <a:srgbClr val="3B82F6"/>
+                </a:solidFill>
+                <a:latin typeface="Calibri"/>
+              </a:rPr>
+              <a:t>[ TIER 1 ]  CLIENT LAYER  -  React 19</a:t>
+            </a:r>
+          </a:p>
+        </p:txBody>
+      </p:sp>
+      <p:sp>
+        <p:nvSpPr>
+          <p:cNvPr id="976" name="s"/>
+          <p:cNvSpPr/>
+          <p:nvPr/>
+        </p:nvSpPr>
+        <p:spPr>
+          <a:xfrm>
+            <a:off x="548640" y="1645920"/>
+            <a:ext cx="3611880" cy="365760"/>
+          </a:xfrm>
+          <a:prstGeom prst="roundRect">
+            <a:avLst>
+              <a:gd name="adj" fmla="val 6000"/>
+            </a:avLst>
+          </a:prstGeom>
+          <a:solidFill>
+            <a:srgbClr val="3B82F6"/>
+          </a:solidFill>
+          <a:ln>
+            <a:noFill/>
+          </a:ln>
+          <a:effectLst>
+            <a:outerShdw blurRad="50800" dist="38100" dir="2700000" rotWithShape="0">
+              <a:srgbClr val="000000">
+                <a:alpha val="35000"/>
+              </a:srgbClr>
+            </a:outerShdw>
+          </a:effectLst>
+        </p:spPr>
+        <p:txBody>
+          <a:bodyPr wrap="square" anchor="ctr" rtlCol="0" lIns="91440" tIns="91440" rIns="91440" bIns="91440"/>
+          <a:lstStyle/>
+          <a:p>
+            <a:pPr algn="ctr">
+              <a:buNone/>
+            </a:pPr>
+            <a:r>
+              <a:rPr lang="en-US" sz="1100" b="1" dirty="0">
+                <a:solidFill>
+                  <a:srgbClr val="FFFFFF"/>
+                </a:solidFill>
+                <a:latin typeface="Calibri"/>
+              </a:rPr>
+              <a:t>CUSTOMER APP</a:t>
+            </a:r>
+          </a:p>
+        </p:txBody>
+      </p:sp>
+      <p:sp>
+        <p:nvSpPr>
+          <p:cNvPr id="977" name="t"/>
+          <p:cNvSpPr txBox="1"/>
+          <p:nvPr/>
+        </p:nvSpPr>
+        <p:spPr>
+          <a:xfrm>
+            <a:off x="548640" y="2011680"/>
+            <a:ext cx="3611880" cy="164592"/>
+          </a:xfrm>
+          <a:prstGeom prst="rect">
+            <a:avLst/>
+          </a:prstGeom>
+          <a:noFill/>
+        </p:spPr>
+        <p:txBody>
+          <a:bodyPr wrap="square" anchor="t" rtlCol="0"/>
+          <a:lstStyle/>
+          <a:p>
+            <a:pPr algn="ctr">
+              <a:buNone/>
+            </a:pPr>
+            <a:r>
+              <a:rPr lang="en-US" sz="800" dirty="0">
+                <a:solidFill>
+                  <a:srgbClr val="475569"/>
+                </a:solidFill>
+                <a:latin typeface="Calibri"/>
+              </a:rPr>
+              <a:t>Book  -  Track  -  Chat  -  Rate</a:t>
+            </a:r>
+          </a:p>
+        </p:txBody>
+      </p:sp>
+      <p:sp>
+        <p:nvSpPr>
+          <p:cNvPr id="978" name="s"/>
+          <p:cNvSpPr/>
+          <p:nvPr/>
+        </p:nvSpPr>
+        <p:spPr>
+          <a:xfrm>
+            <a:off x="4343400" y="1645920"/>
+            <a:ext cx="3611880" cy="365760"/>
+          </a:xfrm>
+          <a:prstGeom prst="roundRect">
+            <a:avLst>
+              <a:gd name="adj" fmla="val 6000"/>
+            </a:avLst>
+          </a:prstGeom>
+          <a:solidFill>
+            <a:srgbClr val="F97316"/>
+          </a:solidFill>
+          <a:ln>
+            <a:noFill/>
+          </a:ln>
+          <a:effectLst>
+            <a:outerShdw blurRad="50800" dist="38100" dir="2700000" rotWithShape="0">
+              <a:srgbClr val="000000">
+                <a:alpha val="35000"/>
+              </a:srgbClr>
+            </a:outerShdw>
+          </a:effectLst>
+        </p:spPr>
+        <p:txBody>
+          <a:bodyPr wrap="square" anchor="ctr" rtlCol="0" lIns="91440" tIns="91440" rIns="91440" bIns="91440"/>
+          <a:lstStyle/>
+          <a:p>
+            <a:pPr algn="ctr">
+              <a:buNone/>
+            </a:pPr>
+            <a:r>
+              <a:rPr lang="en-US" sz="1100" b="1" dirty="0">
+                <a:solidFill>
+                  <a:srgbClr val="FFFFFF"/>
+                </a:solidFill>
+                <a:latin typeface="Calibri"/>
+              </a:rPr>
+              <a:t>ADMIN PANEL</a:t>
+            </a:r>
+          </a:p>
+        </p:txBody>
+      </p:sp>
+      <p:sp>
+        <p:nvSpPr>
+          <p:cNvPr id="979" name="t"/>
+          <p:cNvSpPr txBox="1"/>
+          <p:nvPr/>
+        </p:nvSpPr>
+        <p:spPr>
+          <a:xfrm>
+            <a:off x="4343400" y="2011680"/>
+            <a:ext cx="3611880" cy="164592"/>
+          </a:xfrm>
+          <a:prstGeom prst="rect">
+            <a:avLst/>
+          </a:prstGeom>
+          <a:noFill/>
+        </p:spPr>
+        <p:txBody>
+          <a:bodyPr wrap="square" anchor="t" rtlCol="0"/>
+          <a:lstStyle/>
+          <a:p>
+            <a:pPr algn="ctr">
+              <a:buNone/>
+            </a:pPr>
+            <a:r>
+              <a:rPr lang="en-US" sz="800" dirty="0">
+                <a:solidFill>
+                  <a:srgbClr val="475569"/>
+                </a:solidFill>
+                <a:latin typeface="Calibri"/>
+              </a:rPr>
+              <a:t>Dispatch  -  Crisis  -  Analytics</a:t>
+            </a:r>
+          </a:p>
+        </p:txBody>
+      </p:sp>
+      <p:sp>
+        <p:nvSpPr>
+          <p:cNvPr id="980" name="s"/>
+          <p:cNvSpPr/>
+          <p:nvPr/>
+        </p:nvSpPr>
+        <p:spPr>
+          <a:xfrm>
+            <a:off x="8138160" y="1645920"/>
+            <a:ext cx="3611880" cy="365760"/>
+          </a:xfrm>
+          <a:prstGeom prst="roundRect">
+            <a:avLst>
+              <a:gd name="adj" fmla="val 6000"/>
+            </a:avLst>
+          </a:prstGeom>
+          <a:solidFill>
+            <a:srgbClr val="10B981"/>
+          </a:solidFill>
+          <a:ln>
+            <a:noFill/>
+          </a:ln>
+          <a:effectLst>
+            <a:outerShdw blurRad="50800" dist="38100" dir="2700000" rotWithShape="0">
+              <a:srgbClr val="000000">
+                <a:alpha val="35000"/>
+              </a:srgbClr>
+            </a:outerShdw>
+          </a:effectLst>
+        </p:spPr>
+        <p:txBody>
+          <a:bodyPr wrap="square" anchor="ctr" rtlCol="0" lIns="91440" tIns="91440" rIns="91440" bIns="91440"/>
+          <a:lstStyle/>
+          <a:p>
+            <a:pPr algn="ctr">
+              <a:buNone/>
+            </a:pPr>
+            <a:r>
+              <a:rPr lang="en-US" sz="1100" b="1" dirty="0">
+                <a:solidFill>
+                  <a:srgbClr val="FFFFFF"/>
+                </a:solidFill>
+                <a:latin typeface="Calibri"/>
+              </a:rPr>
+              <a:t>AGENT APP</a:t>
+            </a:r>
+          </a:p>
+        </p:txBody>
+      </p:sp>
+      <p:sp>
+        <p:nvSpPr>
+          <p:cNvPr id="981" name="t"/>
+          <p:cNvSpPr txBox="1"/>
+          <p:nvPr/>
+        </p:nvSpPr>
+        <p:spPr>
+          <a:xfrm>
+            <a:off x="8138160" y="2011680"/>
+            <a:ext cx="3611880" cy="164592"/>
+          </a:xfrm>
+          <a:prstGeom prst="rect">
+            <a:avLst/>
+          </a:prstGeom>
+          <a:noFill/>
+        </p:spPr>
+        <p:txBody>
+          <a:bodyPr wrap="square" anchor="t" rtlCol="0"/>
+          <a:lstStyle/>
+          <a:p>
+            <a:pPr algn="ctr">
+              <a:buNone/>
+            </a:pPr>
+            <a:r>
+              <a:rPr lang="en-US" sz="800" dirty="0">
+                <a:solidFill>
+                  <a:srgbClr val="475569"/>
+                </a:solidFill>
+                <a:latin typeface="Calibri"/>
+              </a:rPr>
+              <a:t>GPS  -  Photo Proof  -  Chat</a:t>
+            </a:r>
+          </a:p>
+        </p:txBody>
+      </p:sp>
+      <p:sp>
+        <p:nvSpPr>
+          <p:cNvPr id="982" name="t"/>
+          <p:cNvSpPr txBox="1"/>
+          <p:nvPr/>
+        </p:nvSpPr>
+        <p:spPr>
+          <a:xfrm>
+            <a:off x="2286000" y="2240280"/>
+            <a:ext cx="1828800" cy="182880"/>
+          </a:xfrm>
+          <a:prstGeom prst="rect">
+            <a:avLst/>
+          </a:prstGeom>
+          <a:noFill/>
+        </p:spPr>
+        <p:txBody>
+          <a:bodyPr wrap="square" anchor="t" rtlCol="0"/>
+          <a:lstStyle/>
+          <a:p>
+            <a:pPr algn="ctr">
+              <a:buNone/>
+            </a:pPr>
+            <a:r>
+              <a:rPr lang="en-US" sz="800" b="1" dirty="0">
+                <a:solidFill>
+                  <a:srgbClr val="94A3B8"/>
+                </a:solidFill>
+                <a:latin typeface="Calibri"/>
+              </a:rPr>
+              <a:t>HTTP REST</a:t>
+            </a:r>
+          </a:p>
+        </p:txBody>
+      </p:sp>
+      <p:cxnSp>
+        <p:nvCxnSpPr>
+          <p:cNvPr id="983" name="ln"/>
+          <p:cNvCxnSpPr/>
+          <p:nvPr/>
+        </p:nvCxnSpPr>
+        <p:spPr>
+          <a:xfrm flipH="0" flipV="0">
+            <a:off x="3200400" y="2194560"/>
+            <a:ext cx="1" cy="228600"/>
+          </a:xfrm>
+          <a:prstGeom prst="line">
+            <a:avLst/>
+          </a:prstGeom>
+          <a:ln w="15000">
+            <a:solidFill>
+              <a:srgbClr val="94A3B8"/>
+            </a:solidFill>
+          </a:ln>
+        </p:spPr>
+      </p:cxnSp>
+      <p:sp>
+        <p:nvSpPr>
+          <p:cNvPr id="984" name="t"/>
+          <p:cNvSpPr txBox="1"/>
+          <p:nvPr/>
+        </p:nvSpPr>
+        <p:spPr>
+          <a:xfrm>
+            <a:off x="7772400" y="2240280"/>
+            <a:ext cx="1828800" cy="182880"/>
+          </a:xfrm>
+          <a:prstGeom prst="rect">
+            <a:avLst/>
+          </a:prstGeom>
+          <a:noFill/>
+        </p:spPr>
+        <p:txBody>
+          <a:bodyPr wrap="square" anchor="t" rtlCol="0"/>
+          <a:lstStyle/>
+          <a:p>
+            <a:pPr algn="ctr">
+              <a:buNone/>
+            </a:pPr>
+            <a:r>
+              <a:rPr lang="en-US" sz="800" b="1" dirty="0">
+                <a:solidFill>
+                  <a:srgbClr val="94A3B8"/>
+                </a:solidFill>
+                <a:latin typeface="Calibri"/>
+              </a:rPr>
+              <a:t>WebSocket (Socket.IO)</a:t>
+            </a:r>
+          </a:p>
+        </p:txBody>
+      </p:sp>
+      <p:cxnSp>
+        <p:nvCxnSpPr>
+          <p:cNvPr id="985" name="ln"/>
+          <p:cNvCxnSpPr/>
+          <p:nvPr/>
+        </p:nvCxnSpPr>
+        <p:spPr>
+          <a:xfrm flipH="0" flipV="0">
+            <a:off x="8686800" y="2194560"/>
+            <a:ext cx="1" cy="228600"/>
+          </a:xfrm>
+          <a:prstGeom prst="line">
+            <a:avLst/>
+          </a:prstGeom>
+          <a:ln w="15000">
+            <a:solidFill>
+              <a:srgbClr val="94A3B8"/>
+            </a:solidFill>
+          </a:ln>
+        </p:spPr>
+      </p:cxnSp>
+      <p:sp>
+        <p:nvSpPr>
+          <p:cNvPr id="986" name="s"/>
+          <p:cNvSpPr/>
+          <p:nvPr/>
+        </p:nvSpPr>
+        <p:spPr>
+          <a:xfrm>
+            <a:off x="365760" y="2423160"/>
+            <a:ext cx="11430000" cy="1280160"/>
+          </a:xfrm>
+          <a:prstGeom prst="roundRect">
+            <a:avLst>
+              <a:gd name="adj" fmla="val 8000"/>
+            </a:avLst>
+          </a:prstGeom>
+          <a:solidFill>
+            <a:srgbClr val="0B1739"/>
+          </a:solidFill>
+          <a:ln>
+            <a:noFill/>
+          </a:ln>
+          <a:effectLst>
+            <a:outerShdw blurRad="50800" dist="38100" dir="2700000" rotWithShape="0">
+              <a:srgbClr val="000000">
+                <a:alpha val="35000"/>
+              </a:srgbClr>
+            </a:outerShdw>
+          </a:effectLst>
+        </p:spPr>
+        <p:txBody>
+          <a:bodyPr wrap="square" anchor="ctr" rtlCol="0" lIns="91440" tIns="91440" rIns="91440" bIns="91440"/>
+          <a:lstStyle/>
+          <a:p/>
+        </p:txBody>
+      </p:sp>
+      <p:sp>
+        <p:nvSpPr>
+          <p:cNvPr id="987" name="r"/>
+          <p:cNvSpPr/>
+          <p:nvPr/>
+        </p:nvSpPr>
+        <p:spPr>
+          <a:xfrm>
+            <a:off x="365760" y="2423160"/>
+            <a:ext cx="11430000" cy="54864"/>
+          </a:xfrm>
+          <a:prstGeom prst="rect">
+            <a:avLst/>
+          </a:prstGeom>
+          <a:solidFill>
+            <a:srgbClr val="F97316"/>
+          </a:solidFill>
+          <a:ln>
+            <a:noFill/>
+          </a:ln>
+        </p:spPr>
+        <p:txBody>
+          <a:bodyPr/>
+          <a:lstStyle/>
+          <a:p/>
+        </p:txBody>
+      </p:sp>
+      <p:sp>
+        <p:nvSpPr>
+          <p:cNvPr id="988" name="t"/>
+          <p:cNvSpPr txBox="1"/>
+          <p:nvPr/>
+        </p:nvSpPr>
+        <p:spPr>
+          <a:xfrm>
+            <a:off x="548640" y="2496312"/>
+            <a:ext cx="7315200" cy="274320"/>
+          </a:xfrm>
+          <a:prstGeom prst="rect">
+            <a:avLst/>
+          </a:prstGeom>
+          <a:noFill/>
+        </p:spPr>
+        <p:txBody>
+          <a:bodyPr wrap="square" anchor="t" rtlCol="0"/>
+          <a:lstStyle/>
+          <a:p>
+            <a:pPr algn="l">
+              <a:buNone/>
+            </a:pPr>
+            <a:r>
+              <a:rPr lang="en-US" sz="1000" b="1" dirty="0">
+                <a:solidFill>
+                  <a:srgbClr val="FBBF24"/>
+                </a:solidFill>
+                <a:latin typeface="Calibri"/>
+              </a:rPr>
+              <a:t>[ TIER 2 ]  API GATEWAY  -  Node.js + Express + Socket.IO</a:t>
+            </a:r>
+          </a:p>
+        </p:txBody>
+      </p:sp>
+      <p:sp>
+        <p:nvSpPr>
+          <p:cNvPr id="989" name="s"/>
+          <p:cNvSpPr/>
+          <p:nvPr/>
+        </p:nvSpPr>
+        <p:spPr>
+          <a:xfrm>
+            <a:off x="548640" y="2788920"/>
+            <a:ext cx="1188720" cy="292608"/>
+          </a:xfrm>
+          <a:prstGeom prst="roundRect">
+            <a:avLst>
+              <a:gd name="adj" fmla="val 20000"/>
+            </a:avLst>
+          </a:prstGeom>
+          <a:solidFill>
+            <a:srgbClr val="3B82F6"/>
+          </a:solidFill>
+          <a:ln>
+            <a:noFill/>
+          </a:ln>
+        </p:spPr>
+        <p:txBody>
+          <a:bodyPr wrap="square" anchor="ctr" rtlCol="0" lIns="91440" tIns="91440" rIns="91440" bIns="91440"/>
+          <a:lstStyle/>
+          <a:p>
+            <a:pPr algn="ctr">
+              <a:buNone/>
+            </a:pPr>
+            <a:r>
+              <a:rPr lang="en-US" sz="900" b="1" dirty="0">
+                <a:solidFill>
+                  <a:srgbClr val="FFFFFF"/>
+                </a:solidFill>
+                <a:latin typeface="Calibri"/>
+              </a:rPr>
+              <a:t>Auth</a:t>
+            </a:r>
+          </a:p>
+        </p:txBody>
+      </p:sp>
+      <p:sp>
+        <p:nvSpPr>
+          <p:cNvPr id="990" name="s"/>
+          <p:cNvSpPr/>
+          <p:nvPr/>
+        </p:nvSpPr>
+        <p:spPr>
+          <a:xfrm>
+            <a:off x="1792224" y="2788920"/>
+            <a:ext cx="1188720" cy="292608"/>
+          </a:xfrm>
+          <a:prstGeom prst="roundRect">
+            <a:avLst>
+              <a:gd name="adj" fmla="val 20000"/>
+            </a:avLst>
+          </a:prstGeom>
+          <a:solidFill>
+            <a:srgbClr val="F97316"/>
+          </a:solidFill>
+          <a:ln>
+            <a:noFill/>
+          </a:ln>
+        </p:spPr>
+        <p:txBody>
+          <a:bodyPr wrap="square" anchor="ctr" rtlCol="0" lIns="91440" tIns="91440" rIns="91440" bIns="91440"/>
+          <a:lstStyle/>
+          <a:p>
+            <a:pPr algn="ctr">
+              <a:buNone/>
+            </a:pPr>
+            <a:r>
+              <a:rPr lang="en-US" sz="900" b="1" dirty="0">
+                <a:solidFill>
+                  <a:srgbClr val="FFFFFF"/>
+                </a:solidFill>
+                <a:latin typeface="Calibri"/>
+              </a:rPr>
+              <a:t>Orders</a:t>
+            </a:r>
+          </a:p>
+        </p:txBody>
+      </p:sp>
+      <p:sp>
+        <p:nvSpPr>
+          <p:cNvPr id="991" name="s"/>
+          <p:cNvSpPr/>
+          <p:nvPr/>
+        </p:nvSpPr>
+        <p:spPr>
+          <a:xfrm>
+            <a:off x="3035808" y="2788920"/>
+            <a:ext cx="1188720" cy="292608"/>
+          </a:xfrm>
+          <a:prstGeom prst="roundRect">
+            <a:avLst>
+              <a:gd name="adj" fmla="val 20000"/>
+            </a:avLst>
+          </a:prstGeom>
+          <a:solidFill>
+            <a:srgbClr val="8B5CF6"/>
+          </a:solidFill>
+          <a:ln>
+            <a:noFill/>
+          </a:ln>
+        </p:spPr>
+        <p:txBody>
+          <a:bodyPr wrap="square" anchor="ctr" rtlCol="0" lIns="91440" tIns="91440" rIns="91440" bIns="91440"/>
+          <a:lstStyle/>
+          <a:p>
+            <a:pPr algn="ctr">
+              <a:buNone/>
+            </a:pPr>
+            <a:r>
+              <a:rPr lang="en-US" sz="900" b="1" dirty="0">
+                <a:solidFill>
+                  <a:srgbClr val="FFFFFF"/>
+                </a:solidFill>
+                <a:latin typeface="Calibri"/>
+              </a:rPr>
+              <a:t>Dispatch</a:t>
+            </a:r>
+          </a:p>
+        </p:txBody>
+      </p:sp>
+      <p:sp>
+        <p:nvSpPr>
+          <p:cNvPr id="992" name="s"/>
+          <p:cNvSpPr/>
+          <p:nvPr/>
+        </p:nvSpPr>
+        <p:spPr>
+          <a:xfrm>
+            <a:off x="4279392" y="2788920"/>
+            <a:ext cx="1188720" cy="292608"/>
+          </a:xfrm>
+          <a:prstGeom prst="roundRect">
+            <a:avLst>
+              <a:gd name="adj" fmla="val 20000"/>
+            </a:avLst>
+          </a:prstGeom>
+          <a:solidFill>
+            <a:srgbClr val="EF4444"/>
+          </a:solidFill>
+          <a:ln>
+            <a:noFill/>
+          </a:ln>
+        </p:spPr>
+        <p:txBody>
+          <a:bodyPr wrap="square" anchor="ctr" rtlCol="0" lIns="91440" tIns="91440" rIns="91440" bIns="91440"/>
+          <a:lstStyle/>
+          <a:p>
+            <a:pPr algn="ctr">
+              <a:buNone/>
+            </a:pPr>
+            <a:r>
+              <a:rPr lang="en-US" sz="900" b="1" dirty="0">
+                <a:solidFill>
+                  <a:srgbClr val="FFFFFF"/>
+                </a:solidFill>
+                <a:latin typeface="Calibri"/>
+              </a:rPr>
+              <a:t>Crisis</a:t>
+            </a:r>
+          </a:p>
+        </p:txBody>
+      </p:sp>
+      <p:sp>
+        <p:nvSpPr>
+          <p:cNvPr id="993" name="s"/>
+          <p:cNvSpPr/>
+          <p:nvPr/>
+        </p:nvSpPr>
+        <p:spPr>
+          <a:xfrm>
+            <a:off x="5522976" y="2788920"/>
+            <a:ext cx="1188720" cy="292608"/>
+          </a:xfrm>
+          <a:prstGeom prst="roundRect">
+            <a:avLst>
+              <a:gd name="adj" fmla="val 20000"/>
+            </a:avLst>
+          </a:prstGeom>
+          <a:solidFill>
+            <a:srgbClr val="14B8A6"/>
+          </a:solidFill>
+          <a:ln>
+            <a:noFill/>
+          </a:ln>
+        </p:spPr>
+        <p:txBody>
+          <a:bodyPr wrap="square" anchor="ctr" rtlCol="0" lIns="91440" tIns="91440" rIns="91440" bIns="91440"/>
+          <a:lstStyle/>
+          <a:p>
+            <a:pPr algn="ctr">
+              <a:buNone/>
+            </a:pPr>
+            <a:r>
+              <a:rPr lang="en-US" sz="900" b="1" dirty="0">
+                <a:solidFill>
+                  <a:srgbClr val="FFFFFF"/>
+                </a:solidFill>
+                <a:latin typeface="Calibri"/>
+              </a:rPr>
+              <a:t>Chat</a:t>
+            </a:r>
+          </a:p>
+        </p:txBody>
+      </p:sp>
+      <p:sp>
+        <p:nvSpPr>
+          <p:cNvPr id="994" name="s"/>
+          <p:cNvSpPr/>
+          <p:nvPr/>
+        </p:nvSpPr>
+        <p:spPr>
+          <a:xfrm>
+            <a:off x="6766560" y="2788920"/>
+            <a:ext cx="1188720" cy="292608"/>
+          </a:xfrm>
+          <a:prstGeom prst="roundRect">
+            <a:avLst>
+              <a:gd name="adj" fmla="val 20000"/>
+            </a:avLst>
+          </a:prstGeom>
+          <a:solidFill>
+            <a:srgbClr val="10B981"/>
+          </a:solidFill>
+          <a:ln>
+            <a:noFill/>
+          </a:ln>
+        </p:spPr>
+        <p:txBody>
+          <a:bodyPr wrap="square" anchor="ctr" rtlCol="0" lIns="91440" tIns="91440" rIns="91440" bIns="91440"/>
+          <a:lstStyle/>
+          <a:p>
+            <a:pPr algn="ctr">
+              <a:buNone/>
+            </a:pPr>
+            <a:r>
+              <a:rPr lang="en-US" sz="900" b="1" dirty="0">
+                <a:solidFill>
+                  <a:srgbClr val="FFFFFF"/>
+                </a:solidFill>
+                <a:latin typeface="Calibri"/>
+              </a:rPr>
+              <a:t>Inventory</a:t>
+            </a:r>
+          </a:p>
+        </p:txBody>
+      </p:sp>
+      <p:sp>
+        <p:nvSpPr>
+          <p:cNvPr id="995" name="s"/>
+          <p:cNvSpPr/>
+          <p:nvPr/>
+        </p:nvSpPr>
+        <p:spPr>
+          <a:xfrm>
+            <a:off x="8010144" y="2788920"/>
+            <a:ext cx="1188720" cy="292608"/>
+          </a:xfrm>
+          <a:prstGeom prst="roundRect">
+            <a:avLst>
+              <a:gd name="adj" fmla="val 20000"/>
+            </a:avLst>
+          </a:prstGeom>
+          <a:solidFill>
+            <a:srgbClr val="FBBF24"/>
+          </a:solidFill>
+          <a:ln>
+            <a:noFill/>
+          </a:ln>
+        </p:spPr>
+        <p:txBody>
+          <a:bodyPr wrap="square" anchor="ctr" rtlCol="0" lIns="91440" tIns="91440" rIns="91440" bIns="91440"/>
+          <a:lstStyle/>
+          <a:p>
+            <a:pPr algn="ctr">
+              <a:buNone/>
+            </a:pPr>
+            <a:r>
+              <a:rPr lang="en-US" sz="900" b="1" dirty="0">
+                <a:solidFill>
+                  <a:srgbClr val="FFFFFF"/>
+                </a:solidFill>
+                <a:latin typeface="Calibri"/>
+              </a:rPr>
+              <a:t>Delivery</a:t>
+            </a:r>
+          </a:p>
+        </p:txBody>
+      </p:sp>
+      <p:sp>
+        <p:nvSpPr>
+          <p:cNvPr id="996" name="s"/>
+          <p:cNvSpPr/>
+          <p:nvPr/>
+        </p:nvSpPr>
+        <p:spPr>
+          <a:xfrm>
+            <a:off x="9253728" y="2788920"/>
+            <a:ext cx="1188720" cy="292608"/>
+          </a:xfrm>
+          <a:prstGeom prst="roundRect">
+            <a:avLst>
+              <a:gd name="adj" fmla="val 20000"/>
+            </a:avLst>
+          </a:prstGeom>
+          <a:solidFill>
+            <a:srgbClr val="EA580C"/>
+          </a:solidFill>
+          <a:ln>
+            <a:noFill/>
+          </a:ln>
+        </p:spPr>
+        <p:txBody>
+          <a:bodyPr wrap="square" anchor="ctr" rtlCol="0" lIns="91440" tIns="91440" rIns="91440" bIns="91440"/>
+          <a:lstStyle/>
+          <a:p>
+            <a:pPr algn="ctr">
+              <a:buNone/>
+            </a:pPr>
+            <a:r>
+              <a:rPr lang="en-US" sz="900" b="1" dirty="0">
+                <a:solidFill>
+                  <a:srgbClr val="FFFFFF"/>
+                </a:solidFill>
+                <a:latin typeface="Calibri"/>
+              </a:rPr>
+              <a:t>Notify</a:t>
+            </a:r>
+          </a:p>
+        </p:txBody>
+      </p:sp>
+      <p:sp>
+        <p:nvSpPr>
+          <p:cNvPr id="997" name="s"/>
+          <p:cNvSpPr/>
+          <p:nvPr/>
+        </p:nvSpPr>
+        <p:spPr>
+          <a:xfrm>
+            <a:off x="10497312" y="2788920"/>
+            <a:ext cx="1188720" cy="292608"/>
+          </a:xfrm>
+          <a:prstGeom prst="roundRect">
+            <a:avLst>
+              <a:gd name="adj" fmla="val 20000"/>
+            </a:avLst>
+          </a:prstGeom>
+          <a:solidFill>
+            <a:srgbClr val="8B5CF6"/>
+          </a:solidFill>
+          <a:ln>
+            <a:noFill/>
+          </a:ln>
+        </p:spPr>
+        <p:txBody>
+          <a:bodyPr wrap="square" anchor="ctr" rtlCol="0" lIns="91440" tIns="91440" rIns="91440" bIns="91440"/>
+          <a:lstStyle/>
+          <a:p>
+            <a:pPr algn="ctr">
+              <a:buNone/>
+            </a:pPr>
+            <a:r>
+              <a:rPr lang="en-US" sz="900" b="1" dirty="0">
+                <a:solidFill>
+                  <a:srgbClr val="FFFFFF"/>
+                </a:solidFill>
+                <a:latin typeface="Calibri"/>
+              </a:rPr>
+              <a:t>Support</a:t>
+            </a:r>
+          </a:p>
+        </p:txBody>
+      </p:sp>
+      <p:sp>
+        <p:nvSpPr>
+          <p:cNvPr id="998" name="t"/>
+          <p:cNvSpPr txBox="1"/>
+          <p:nvPr/>
+        </p:nvSpPr>
+        <p:spPr>
+          <a:xfrm>
+            <a:off x="548640" y="3172968"/>
+            <a:ext cx="3657600" cy="201168"/>
+          </a:xfrm>
+          <a:prstGeom prst="rect">
+            <a:avLst/>
+          </a:prstGeom>
+          <a:noFill/>
+        </p:spPr>
+        <p:txBody>
+          <a:bodyPr wrap="square" anchor="t" rtlCol="0"/>
+          <a:lstStyle/>
+          <a:p>
+            <a:pPr algn="l">
+              <a:buNone/>
+            </a:pPr>
+            <a:r>
+              <a:rPr lang="en-US" sz="800" b="1" dirty="0">
+                <a:solidFill>
+                  <a:srgbClr val="FBBF24"/>
+                </a:solidFill>
+                <a:latin typeface="Calibri"/>
+              </a:rPr>
+              <a:t>MIDDLEWARE CHAIN:</a:t>
+            </a:r>
+          </a:p>
+        </p:txBody>
+      </p:sp>
+      <p:sp>
+        <p:nvSpPr>
+          <p:cNvPr id="999" name="r"/>
+          <p:cNvSpPr/>
+          <p:nvPr/>
+        </p:nvSpPr>
+        <p:spPr>
+          <a:xfrm>
+            <a:off x="548640" y="3383280"/>
+            <a:ext cx="11064240" cy="246888"/>
+          </a:xfrm>
+          <a:prstGeom prst="roundRect">
+            <a:avLst>
+              <a:gd name="adj" fmla="val 4000"/>
+            </a:avLst>
+          </a:prstGeom>
+          <a:solidFill>
+            <a:srgbClr val="060E26"/>
+          </a:solidFill>
+          <a:ln>
+            <a:noFill/>
+          </a:ln>
+        </p:spPr>
+        <p:txBody>
+          <a:bodyPr/>
+          <a:lstStyle/>
+          <a:p/>
+        </p:txBody>
+      </p:sp>
+      <p:sp>
+        <p:nvSpPr>
+          <p:cNvPr id="1000" name="t"/>
+          <p:cNvSpPr txBox="1"/>
+          <p:nvPr/>
+        </p:nvSpPr>
+        <p:spPr>
+          <a:xfrm>
+            <a:off x="640080" y="3410712"/>
+            <a:ext cx="10972800" cy="201168"/>
+          </a:xfrm>
+          <a:prstGeom prst="rect">
+            <a:avLst/>
+          </a:prstGeom>
+          <a:noFill/>
+        </p:spPr>
+        <p:txBody>
+          <a:bodyPr wrap="square" anchor="t" rtlCol="0"/>
+          <a:lstStyle/>
+          <a:p>
+            <a:pPr algn="l">
+              <a:buNone/>
+            </a:pPr>
+            <a:r>
+              <a:rPr lang="en-US" sz="800" dirty="0">
+                <a:solidFill>
+                  <a:srgbClr val="94A3B8"/>
+                </a:solidFill>
+                <a:latin typeface="Calibri"/>
+              </a:rPr>
+              <a:t>Helmet  |  CORS  |  Rate Limiter (100/15min)  |  JWT Auth (15m+7d)  |  RBAC  |  Mongo Sanitize  |  XSS Clean  |  HPP</a:t>
+            </a:r>
+          </a:p>
+        </p:txBody>
+      </p:sp>
+      <p:cxnSp>
+        <p:nvCxnSpPr>
+          <p:cNvPr id="1001" name="ln"/>
+          <p:cNvCxnSpPr/>
+          <p:nvPr/>
+        </p:nvCxnSpPr>
+        <p:spPr>
+          <a:xfrm flipH="0" flipV="0">
+            <a:off x="2743200" y="3703320"/>
+            <a:ext cx="1" cy="182880"/>
+          </a:xfrm>
+          <a:prstGeom prst="line">
+            <a:avLst/>
+          </a:prstGeom>
+          <a:ln w="15000">
+            <a:solidFill>
+              <a:srgbClr val="94A3B8"/>
+            </a:solidFill>
+          </a:ln>
+        </p:spPr>
+      </p:cxnSp>
+      <p:cxnSp>
+        <p:nvCxnSpPr>
+          <p:cNvPr id="1002" name="ln"/>
+          <p:cNvCxnSpPr/>
+          <p:nvPr/>
+        </p:nvCxnSpPr>
+        <p:spPr>
+          <a:xfrm flipH="0" flipV="0">
+            <a:off x="6126480" y="3703320"/>
+            <a:ext cx="1" cy="182880"/>
+          </a:xfrm>
+          <a:prstGeom prst="line">
+            <a:avLst/>
+          </a:prstGeom>
+          <a:ln w="15000">
+            <a:solidFill>
+              <a:srgbClr val="94A3B8"/>
+            </a:solidFill>
+          </a:ln>
+        </p:spPr>
+      </p:cxnSp>
+      <p:cxnSp>
+        <p:nvCxnSpPr>
+          <p:cNvPr id="1003" name="ln"/>
+          <p:cNvCxnSpPr/>
+          <p:nvPr/>
+        </p:nvCxnSpPr>
+        <p:spPr>
+          <a:xfrm flipH="0" flipV="0">
+            <a:off x="9144000" y="3703320"/>
+            <a:ext cx="1" cy="182880"/>
+          </a:xfrm>
+          <a:prstGeom prst="line">
+            <a:avLst/>
+          </a:prstGeom>
+          <a:ln w="15000">
+            <a:solidFill>
+              <a:srgbClr val="94A3B8"/>
+            </a:solidFill>
+          </a:ln>
+        </p:spPr>
+      </p:cxnSp>
+      <p:sp>
+        <p:nvSpPr>
+          <p:cNvPr id="1004" name="s"/>
+          <p:cNvSpPr/>
+          <p:nvPr/>
+        </p:nvSpPr>
+        <p:spPr>
+          <a:xfrm>
+            <a:off x="365760" y="3931920"/>
+            <a:ext cx="11430000" cy="914400"/>
+          </a:xfrm>
+          <a:prstGeom prst="roundRect">
+            <a:avLst>
+              <a:gd name="adj" fmla="val 8000"/>
+            </a:avLst>
+          </a:prstGeom>
+          <a:solidFill>
+            <a:srgbClr val="FFFFFF"/>
+          </a:solidFill>
+          <a:ln>
+            <a:noFill/>
+          </a:ln>
+          <a:effectLst>
+            <a:outerShdw blurRad="50800" dist="38100" dir="2700000" rotWithShape="0">
+              <a:srgbClr val="000000">
+                <a:alpha val="35000"/>
+              </a:srgbClr>
+            </a:outerShdw>
+          </a:effectLst>
+        </p:spPr>
+        <p:txBody>
+          <a:bodyPr wrap="square" anchor="ctr" rtlCol="0" lIns="91440" tIns="91440" rIns="91440" bIns="91440"/>
+          <a:lstStyle/>
+          <a:p/>
+        </p:txBody>
+      </p:sp>
+      <p:sp>
+        <p:nvSpPr>
+          <p:cNvPr id="1005" name="r"/>
+          <p:cNvSpPr/>
+          <p:nvPr/>
+        </p:nvSpPr>
+        <p:spPr>
+          <a:xfrm>
+            <a:off x="365760" y="3931920"/>
+            <a:ext cx="11430000" cy="54864"/>
+          </a:xfrm>
+          <a:prstGeom prst="rect">
+            <a:avLst/>
+          </a:prstGeom>
+          <a:solidFill>
+            <a:srgbClr val="10B981"/>
+          </a:solidFill>
+          <a:ln>
+            <a:noFill/>
+          </a:ln>
+        </p:spPr>
+        <p:txBody>
+          <a:bodyPr/>
+          <a:lstStyle/>
+          <a:p/>
+        </p:txBody>
+      </p:sp>
+      <p:sp>
+        <p:nvSpPr>
+          <p:cNvPr id="1006" name="t"/>
+          <p:cNvSpPr txBox="1"/>
+          <p:nvPr/>
+        </p:nvSpPr>
+        <p:spPr>
+          <a:xfrm>
+            <a:off x="548640" y="4005072"/>
+            <a:ext cx="7315200" cy="274320"/>
+          </a:xfrm>
+          <a:prstGeom prst="rect">
+            <a:avLst/>
+          </a:prstGeom>
+          <a:noFill/>
+        </p:spPr>
+        <p:txBody>
+          <a:bodyPr wrap="square" anchor="t" rtlCol="0"/>
+          <a:lstStyle/>
+          <a:p>
+            <a:pPr algn="l">
+              <a:buNone/>
+            </a:pPr>
+            <a:r>
+              <a:rPr lang="en-US" sz="1000" b="1" dirty="0">
+                <a:solidFill>
+                  <a:srgbClr val="10B981"/>
+                </a:solidFill>
+                <a:latin typeface="Calibri"/>
+              </a:rPr>
+              <a:t>[ TIER 3 ]  DATA &amp; EXTERNAL SERVICES</a:t>
+            </a:r>
+          </a:p>
+        </p:txBody>
+      </p:sp>
+      <p:sp>
+        <p:nvSpPr>
+          <p:cNvPr id="1007" name="s"/>
+          <p:cNvSpPr/>
+          <p:nvPr/>
+        </p:nvSpPr>
+        <p:spPr>
+          <a:xfrm>
+            <a:off x="548640" y="4297680"/>
+            <a:ext cx="3611880" cy="320040"/>
+          </a:xfrm>
+          <a:prstGeom prst="roundRect">
+            <a:avLst>
+              <a:gd name="adj" fmla="val 6000"/>
+            </a:avLst>
+          </a:prstGeom>
+          <a:solidFill>
+            <a:srgbClr val="10B981"/>
+          </a:solidFill>
+          <a:ln>
+            <a:noFill/>
+          </a:ln>
+          <a:effectLst>
+            <a:outerShdw blurRad="50800" dist="38100" dir="2700000" rotWithShape="0">
+              <a:srgbClr val="000000">
+                <a:alpha val="35000"/>
+              </a:srgbClr>
+            </a:outerShdw>
+          </a:effectLst>
+        </p:spPr>
+        <p:txBody>
+          <a:bodyPr wrap="square" anchor="ctr" rtlCol="0" lIns="91440" tIns="91440" rIns="91440" bIns="91440"/>
+          <a:lstStyle/>
+          <a:p>
+            <a:pPr algn="ctr">
+              <a:buNone/>
+            </a:pPr>
+            <a:r>
+              <a:rPr lang="en-US" sz="1100" b="1" dirty="0">
+                <a:solidFill>
+                  <a:srgbClr val="FFFFFF"/>
+                </a:solidFill>
+                <a:latin typeface="Calibri"/>
+              </a:rPr>
+              <a:t>MongoDB</a:t>
+            </a:r>
+          </a:p>
+        </p:txBody>
+      </p:sp>
+      <p:sp>
+        <p:nvSpPr>
+          <p:cNvPr id="1008" name="t"/>
+          <p:cNvSpPr txBox="1"/>
+          <p:nvPr/>
+        </p:nvSpPr>
+        <p:spPr>
+          <a:xfrm>
+            <a:off x="548640" y="4645152"/>
+            <a:ext cx="3611880" cy="182880"/>
+          </a:xfrm>
+          <a:prstGeom prst="rect">
+            <a:avLst/>
+          </a:prstGeom>
+          <a:noFill/>
+        </p:spPr>
+        <p:txBody>
+          <a:bodyPr wrap="square" anchor="t" rtlCol="0"/>
+          <a:lstStyle/>
+          <a:p>
+            <a:pPr algn="ctr">
+              <a:buNone/>
+            </a:pPr>
+            <a:r>
+              <a:rPr lang="en-US" sz="800" dirty="0">
+                <a:solidFill>
+                  <a:srgbClr val="475569"/>
+                </a:solidFill>
+                <a:latin typeface="Calibri"/>
+              </a:rPr>
+              <a:t>Primary DB - Users, Orders, Inventory, Chat, Routes</a:t>
+            </a:r>
+          </a:p>
+        </p:txBody>
+      </p:sp>
+      <p:sp>
+        <p:nvSpPr>
+          <p:cNvPr id="1009" name="s"/>
+          <p:cNvSpPr/>
+          <p:nvPr/>
+        </p:nvSpPr>
+        <p:spPr>
+          <a:xfrm>
+            <a:off x="4343400" y="4297680"/>
+            <a:ext cx="3611880" cy="320040"/>
+          </a:xfrm>
+          <a:prstGeom prst="roundRect">
+            <a:avLst>
+              <a:gd name="adj" fmla="val 6000"/>
+            </a:avLst>
+          </a:prstGeom>
+          <a:solidFill>
+            <a:srgbClr val="EF4444"/>
+          </a:solidFill>
+          <a:ln>
+            <a:noFill/>
+          </a:ln>
+          <a:effectLst>
+            <a:outerShdw blurRad="50800" dist="38100" dir="2700000" rotWithShape="0">
+              <a:srgbClr val="000000">
+                <a:alpha val="35000"/>
+              </a:srgbClr>
+            </a:outerShdw>
+          </a:effectLst>
+        </p:spPr>
+        <p:txBody>
+          <a:bodyPr wrap="square" anchor="ctr" rtlCol="0" lIns="91440" tIns="91440" rIns="91440" bIns="91440"/>
+          <a:lstStyle/>
+          <a:p>
+            <a:pPr algn="ctr">
+              <a:buNone/>
+            </a:pPr>
+            <a:r>
+              <a:rPr lang="en-US" sz="1100" b="1" dirty="0">
+                <a:solidFill>
+                  <a:srgbClr val="FFFFFF"/>
+                </a:solidFill>
+                <a:latin typeface="Calibri"/>
+              </a:rPr>
+              <a:t>Redis</a:t>
+            </a:r>
+          </a:p>
+        </p:txBody>
+      </p:sp>
+      <p:sp>
+        <p:nvSpPr>
+          <p:cNvPr id="1010" name="t"/>
+          <p:cNvSpPr txBox="1"/>
+          <p:nvPr/>
+        </p:nvSpPr>
+        <p:spPr>
+          <a:xfrm>
+            <a:off x="4343400" y="4645152"/>
+            <a:ext cx="3611880" cy="182880"/>
+          </a:xfrm>
+          <a:prstGeom prst="rect">
+            <a:avLst/>
+          </a:prstGeom>
+          <a:noFill/>
+        </p:spPr>
+        <p:txBody>
+          <a:bodyPr wrap="square" anchor="t" rtlCol="0"/>
+          <a:lstStyle/>
+          <a:p>
+            <a:pPr algn="ctr">
+              <a:buNone/>
+            </a:pPr>
+            <a:r>
+              <a:rPr lang="en-US" sz="800" dirty="0">
+                <a:solidFill>
+                  <a:srgbClr val="475569"/>
+                </a:solidFill>
+                <a:latin typeface="Calibri"/>
+              </a:rPr>
+              <a:t>Cache, GPS Location, Sessions, Rate Limits, OTP</a:t>
+            </a:r>
+          </a:p>
+        </p:txBody>
+      </p:sp>
+      <p:sp>
+        <p:nvSpPr>
+          <p:cNvPr id="1011" name="s"/>
+          <p:cNvSpPr/>
+          <p:nvPr/>
+        </p:nvSpPr>
+        <p:spPr>
+          <a:xfrm>
+            <a:off x="8138160" y="4297680"/>
+            <a:ext cx="3611880" cy="320040"/>
+          </a:xfrm>
+          <a:prstGeom prst="roundRect">
+            <a:avLst>
+              <a:gd name="adj" fmla="val 6000"/>
+            </a:avLst>
+          </a:prstGeom>
+          <a:solidFill>
+            <a:srgbClr val="8B5CF6"/>
+          </a:solidFill>
+          <a:ln>
+            <a:noFill/>
+          </a:ln>
+          <a:effectLst>
+            <a:outerShdw blurRad="50800" dist="38100" dir="2700000" rotWithShape="0">
+              <a:srgbClr val="000000">
+                <a:alpha val="35000"/>
+              </a:srgbClr>
+            </a:outerShdw>
+          </a:effectLst>
+        </p:spPr>
+        <p:txBody>
+          <a:bodyPr wrap="square" anchor="ctr" rtlCol="0" lIns="91440" tIns="91440" rIns="91440" bIns="91440"/>
+          <a:lstStyle/>
+          <a:p>
+            <a:pPr algn="ctr">
+              <a:buNone/>
+            </a:pPr>
+            <a:r>
+              <a:rPr lang="en-US" sz="1100" b="1" dirty="0">
+                <a:solidFill>
+                  <a:srgbClr val="FFFFFF"/>
+                </a:solidFill>
+                <a:latin typeface="Calibri"/>
+              </a:rPr>
+              <a:t>External APIs</a:t>
+            </a:r>
+          </a:p>
+        </p:txBody>
+      </p:sp>
+      <p:sp>
+        <p:nvSpPr>
+          <p:cNvPr id="1012" name="t"/>
+          <p:cNvSpPr txBox="1"/>
+          <p:nvPr/>
+        </p:nvSpPr>
+        <p:spPr>
+          <a:xfrm>
+            <a:off x="8138160" y="4645152"/>
+            <a:ext cx="3611880" cy="182880"/>
+          </a:xfrm>
+          <a:prstGeom prst="rect">
+            <a:avLst/>
+          </a:prstGeom>
+          <a:noFill/>
+        </p:spPr>
+        <p:txBody>
+          <a:bodyPr wrap="square" anchor="t" rtlCol="0"/>
+          <a:lstStyle/>
+          <a:p>
+            <a:pPr algn="ctr">
+              <a:buNone/>
+            </a:pPr>
+            <a:r>
+              <a:rPr lang="en-US" sz="800" dirty="0">
+                <a:solidFill>
+                  <a:srgbClr val="475569"/>
+                </a:solidFill>
+                <a:latin typeface="Calibri"/>
+              </a:rPr>
+              <a:t>Ola Maps, Razorpay, AWS S3, Gmail SMTP, Fast2SMS</a:t>
+            </a:r>
+          </a:p>
+        </p:txBody>
+      </p:sp>
+      <p:sp>
+        <p:nvSpPr>
+          <p:cNvPr id="1013" name="s"/>
+          <p:cNvSpPr/>
+          <p:nvPr/>
+        </p:nvSpPr>
+        <p:spPr>
+          <a:xfrm>
+            <a:off x="365760" y="5029200"/>
+            <a:ext cx="3703320" cy="1554480"/>
+          </a:xfrm>
+          <a:prstGeom prst="roundRect">
+            <a:avLst>
+              <a:gd name="adj" fmla="val 6000"/>
+            </a:avLst>
+          </a:prstGeom>
+          <a:solidFill>
+            <a:srgbClr val="060E26"/>
+          </a:solidFill>
+          <a:ln>
+            <a:noFill/>
+          </a:ln>
+          <a:effectLst>
+            <a:outerShdw blurRad="50800" dist="38100" dir="2700000" rotWithShape="0">
+              <a:srgbClr val="000000">
+                <a:alpha val="35000"/>
+              </a:srgbClr>
+            </a:outerShdw>
+          </a:effectLst>
+        </p:spPr>
+        <p:txBody>
+          <a:bodyPr wrap="square" anchor="ctr" rtlCol="0" lIns="91440" tIns="91440" rIns="91440" bIns="91440"/>
+          <a:lstStyle/>
+          <a:p/>
+        </p:txBody>
+      </p:sp>
+      <p:sp>
+        <p:nvSpPr>
+          <p:cNvPr id="1014" name="r"/>
+          <p:cNvSpPr/>
+          <p:nvPr/>
+        </p:nvSpPr>
+        <p:spPr>
+          <a:xfrm>
+            <a:off x="365760" y="5029200"/>
+            <a:ext cx="3703320" cy="54864"/>
+          </a:xfrm>
+          <a:prstGeom prst="rect">
+            <a:avLst/>
+          </a:prstGeom>
+          <a:solidFill>
+            <a:srgbClr val="FBBF24"/>
+          </a:solidFill>
+          <a:ln>
+            <a:noFill/>
+          </a:ln>
+        </p:spPr>
+        <p:txBody>
+          <a:bodyPr/>
+          <a:lstStyle/>
+          <a:p/>
+        </p:txBody>
+      </p:sp>
+      <p:sp>
+        <p:nvSpPr>
+          <p:cNvPr id="1015" name="t"/>
+          <p:cNvSpPr txBox="1"/>
+          <p:nvPr/>
+        </p:nvSpPr>
+        <p:spPr>
+          <a:xfrm>
+            <a:off x="502920" y="5120640"/>
+            <a:ext cx="3657600" cy="274320"/>
+          </a:xfrm>
+          <a:prstGeom prst="rect">
+            <a:avLst/>
+          </a:prstGeom>
+          <a:noFill/>
+        </p:spPr>
+        <p:txBody>
+          <a:bodyPr wrap="square" anchor="t" rtlCol="0"/>
+          <a:lstStyle/>
+          <a:p>
+            <a:pPr algn="l">
+              <a:buNone/>
+            </a:pPr>
+            <a:r>
+              <a:rPr lang="en-US" sz="1100" b="1" dirty="0">
+                <a:solidFill>
+                  <a:srgbClr val="FBBF24"/>
+                </a:solidFill>
+                <a:latin typeface="Calibri"/>
+              </a:rPr>
+              <a:t>[*]  PERFORMANCE METRICS</a:t>
+            </a:r>
+          </a:p>
+        </p:txBody>
+      </p:sp>
+      <p:sp>
+        <p:nvSpPr>
+          <p:cNvPr id="1016" name="t"/>
+          <p:cNvSpPr txBox="1"/>
+          <p:nvPr/>
+        </p:nvSpPr>
+        <p:spPr>
+          <a:xfrm>
+            <a:off x="502920" y="5440680"/>
+            <a:ext cx="2194560" cy="201168"/>
+          </a:xfrm>
+          <a:prstGeom prst="rect">
+            <a:avLst/>
+          </a:prstGeom>
+          <a:noFill/>
+        </p:spPr>
+        <p:txBody>
+          <a:bodyPr wrap="square" anchor="t" rtlCol="0"/>
+          <a:lstStyle/>
+          <a:p>
+            <a:pPr algn="l">
+              <a:buNone/>
+            </a:pPr>
+            <a:r>
+              <a:rPr lang="en-US" sz="800" dirty="0">
+                <a:solidFill>
+                  <a:srgbClr val="94A3B8"/>
+                </a:solidFill>
+                <a:latin typeface="Calibri"/>
+              </a:rPr>
+              <a:t>Auto-Dispatch (9 ord)</a:t>
+            </a:r>
+          </a:p>
+        </p:txBody>
+      </p:sp>
+      <p:sp>
+        <p:nvSpPr>
+          <p:cNvPr id="1017" name="t"/>
+          <p:cNvSpPr txBox="1"/>
+          <p:nvPr/>
+        </p:nvSpPr>
+        <p:spPr>
+          <a:xfrm>
+            <a:off x="2697480" y="5440680"/>
+            <a:ext cx="1280160" cy="201168"/>
+          </a:xfrm>
+          <a:prstGeom prst="rect">
+            <a:avLst/>
+          </a:prstGeom>
+          <a:noFill/>
+        </p:spPr>
+        <p:txBody>
+          <a:bodyPr wrap="square" anchor="t" rtlCol="0"/>
+          <a:lstStyle/>
+          <a:p>
+            <a:pPr algn="l">
+              <a:buNone/>
+            </a:pPr>
+            <a:r>
+              <a:rPr lang="en-US" sz="800" b="1" dirty="0">
+                <a:solidFill>
+                  <a:srgbClr val="FBBF24"/>
+                </a:solidFill>
+                <a:latin typeface="Calibri"/>
+              </a:rPr>
+              <a:t>55-90 ms</a:t>
+            </a:r>
+          </a:p>
+        </p:txBody>
+      </p:sp>
+      <p:sp>
+        <p:nvSpPr>
+          <p:cNvPr id="1018" name="t"/>
+          <p:cNvSpPr txBox="1"/>
+          <p:nvPr/>
+        </p:nvSpPr>
+        <p:spPr>
+          <a:xfrm>
+            <a:off x="502920" y="5660136"/>
+            <a:ext cx="2194560" cy="201168"/>
+          </a:xfrm>
+          <a:prstGeom prst="rect">
+            <a:avLst/>
+          </a:prstGeom>
+          <a:noFill/>
+        </p:spPr>
+        <p:txBody>
+          <a:bodyPr wrap="square" anchor="t" rtlCol="0"/>
+          <a:lstStyle/>
+          <a:p>
+            <a:pPr algn="l">
+              <a:buNone/>
+            </a:pPr>
+            <a:r>
+              <a:rPr lang="en-US" sz="800" dirty="0">
+                <a:solidFill>
+                  <a:srgbClr val="94A3B8"/>
+                </a:solidFill>
+                <a:latin typeface="Calibri"/>
+              </a:rPr>
+              <a:t>Redis ops / sec</a:t>
+            </a:r>
+          </a:p>
+        </p:txBody>
+      </p:sp>
+      <p:sp>
+        <p:nvSpPr>
+          <p:cNvPr id="1019" name="t"/>
+          <p:cNvSpPr txBox="1"/>
+          <p:nvPr/>
+        </p:nvSpPr>
+        <p:spPr>
+          <a:xfrm>
+            <a:off x="2697480" y="5660136"/>
+            <a:ext cx="1280160" cy="201168"/>
+          </a:xfrm>
+          <a:prstGeom prst="rect">
+            <a:avLst/>
+          </a:prstGeom>
+          <a:noFill/>
+        </p:spPr>
+        <p:txBody>
+          <a:bodyPr wrap="square" anchor="t" rtlCol="0"/>
+          <a:lstStyle/>
+          <a:p>
+            <a:pPr algn="l">
+              <a:buNone/>
+            </a:pPr>
+            <a:r>
+              <a:rPr lang="en-US" sz="800" b="1" dirty="0">
+                <a:solidFill>
+                  <a:srgbClr val="FBBF24"/>
+                </a:solidFill>
+                <a:latin typeface="Calibri"/>
+              </a:rPr>
+              <a:t>6,289 reads</a:t>
+            </a:r>
+          </a:p>
+        </p:txBody>
+      </p:sp>
+      <p:sp>
+        <p:nvSpPr>
+          <p:cNvPr id="1020" name="t"/>
+          <p:cNvSpPr txBox="1"/>
+          <p:nvPr/>
+        </p:nvSpPr>
+        <p:spPr>
+          <a:xfrm>
+            <a:off x="502920" y="5879592"/>
+            <a:ext cx="2194560" cy="201168"/>
+          </a:xfrm>
+          <a:prstGeom prst="rect">
+            <a:avLst/>
+          </a:prstGeom>
+          <a:noFill/>
+        </p:spPr>
+        <p:txBody>
+          <a:bodyPr wrap="square" anchor="t" rtlCol="0"/>
+          <a:lstStyle/>
+          <a:p>
+            <a:pPr algn="l">
+              <a:buNone/>
+            </a:pPr>
+            <a:r>
+              <a:rPr lang="en-US" sz="800" dirty="0">
+                <a:solidFill>
+                  <a:srgbClr val="94A3B8"/>
+                </a:solidFill>
+                <a:latin typeface="Calibri"/>
+              </a:rPr>
+              <a:t>API (cached)</a:t>
+            </a:r>
+          </a:p>
+        </p:txBody>
+      </p:sp>
+      <p:sp>
+        <p:nvSpPr>
+          <p:cNvPr id="1021" name="t"/>
+          <p:cNvSpPr txBox="1"/>
+          <p:nvPr/>
+        </p:nvSpPr>
+        <p:spPr>
+          <a:xfrm>
+            <a:off x="2697480" y="5879592"/>
+            <a:ext cx="1280160" cy="201168"/>
+          </a:xfrm>
+          <a:prstGeom prst="rect">
+            <a:avLst/>
+          </a:prstGeom>
+          <a:noFill/>
+        </p:spPr>
+        <p:txBody>
+          <a:bodyPr wrap="square" anchor="t" rtlCol="0"/>
+          <a:lstStyle/>
+          <a:p>
+            <a:pPr algn="l">
+              <a:buNone/>
+            </a:pPr>
+            <a:r>
+              <a:rPr lang="en-US" sz="800" b="1" dirty="0">
+                <a:solidFill>
+                  <a:srgbClr val="FBBF24"/>
+                </a:solidFill>
+                <a:latin typeface="Calibri"/>
+              </a:rPr>
+              <a:t>&lt; 5 ms</a:t>
+            </a:r>
+          </a:p>
+        </p:txBody>
+      </p:sp>
+      <p:sp>
+        <p:nvSpPr>
+          <p:cNvPr id="1022" name="t"/>
+          <p:cNvSpPr txBox="1"/>
+          <p:nvPr/>
+        </p:nvSpPr>
+        <p:spPr>
+          <a:xfrm>
+            <a:off x="502920" y="6099048"/>
+            <a:ext cx="2194560" cy="201168"/>
+          </a:xfrm>
+          <a:prstGeom prst="rect">
+            <a:avLst/>
+          </a:prstGeom>
+          <a:noFill/>
+        </p:spPr>
+        <p:txBody>
+          <a:bodyPr wrap="square" anchor="t" rtlCol="0"/>
+          <a:lstStyle/>
+          <a:p>
+            <a:pPr algn="l">
+              <a:buNone/>
+            </a:pPr>
+            <a:r>
+              <a:rPr lang="en-US" sz="800" dirty="0">
+                <a:solidFill>
+                  <a:srgbClr val="94A3B8"/>
+                </a:solidFill>
+                <a:latin typeface="Calibri"/>
+              </a:rPr>
+              <a:t>GPS broadcast</a:t>
+            </a:r>
+          </a:p>
+        </p:txBody>
+      </p:sp>
+      <p:sp>
+        <p:nvSpPr>
+          <p:cNvPr id="1023" name="t"/>
+          <p:cNvSpPr txBox="1"/>
+          <p:nvPr/>
+        </p:nvSpPr>
+        <p:spPr>
+          <a:xfrm>
+            <a:off x="2697480" y="6099048"/>
+            <a:ext cx="1280160" cy="201168"/>
+          </a:xfrm>
+          <a:prstGeom prst="rect">
+            <a:avLst/>
+          </a:prstGeom>
+          <a:noFill/>
+        </p:spPr>
+        <p:txBody>
+          <a:bodyPr wrap="square" anchor="t" rtlCol="0"/>
+          <a:lstStyle/>
+          <a:p>
+            <a:pPr algn="l">
+              <a:buNone/>
+            </a:pPr>
+            <a:r>
+              <a:rPr lang="en-US" sz="800" b="1" dirty="0">
+                <a:solidFill>
+                  <a:srgbClr val="FBBF24"/>
+                </a:solidFill>
+                <a:latin typeface="Calibri"/>
+              </a:rPr>
+              <a:t>every 5 s</a:t>
+            </a:r>
+          </a:p>
+        </p:txBody>
+      </p:sp>
+      <p:sp>
+        <p:nvSpPr>
+          <p:cNvPr id="1024" name="t"/>
+          <p:cNvSpPr txBox="1"/>
+          <p:nvPr/>
+        </p:nvSpPr>
+        <p:spPr>
+          <a:xfrm>
+            <a:off x="502920" y="6318504"/>
+            <a:ext cx="2194560" cy="201168"/>
+          </a:xfrm>
+          <a:prstGeom prst="rect">
+            <a:avLst/>
+          </a:prstGeom>
+          <a:noFill/>
+        </p:spPr>
+        <p:txBody>
+          <a:bodyPr wrap="square" anchor="t" rtlCol="0"/>
+          <a:lstStyle/>
+          <a:p>
+            <a:pPr algn="l">
+              <a:buNone/>
+            </a:pPr>
+            <a:r>
+              <a:rPr lang="en-US" sz="800" dirty="0">
+                <a:solidFill>
+                  <a:srgbClr val="94A3B8"/>
+                </a:solidFill>
+                <a:latin typeface="Calibri"/>
+              </a:rPr>
+              <a:t>Concurrent sockets</a:t>
+            </a:r>
+          </a:p>
+        </p:txBody>
+      </p:sp>
+      <p:sp>
+        <p:nvSpPr>
+          <p:cNvPr id="1025" name="t"/>
+          <p:cNvSpPr txBox="1"/>
+          <p:nvPr/>
+        </p:nvSpPr>
+        <p:spPr>
+          <a:xfrm>
+            <a:off x="2697480" y="6318504"/>
+            <a:ext cx="1280160" cy="201168"/>
+          </a:xfrm>
+          <a:prstGeom prst="rect">
+            <a:avLst/>
+          </a:prstGeom>
+          <a:noFill/>
+        </p:spPr>
+        <p:txBody>
+          <a:bodyPr wrap="square" anchor="t" rtlCol="0"/>
+          <a:lstStyle/>
+          <a:p>
+            <a:pPr algn="l">
+              <a:buNone/>
+            </a:pPr>
+            <a:r>
+              <a:rPr lang="en-US" sz="800" b="1" dirty="0">
+                <a:solidFill>
+                  <a:srgbClr val="FBBF24"/>
+                </a:solidFill>
+                <a:latin typeface="Calibri"/>
+              </a:rPr>
+              <a:t>1000+</a:t>
+            </a:r>
+          </a:p>
+        </p:txBody>
+      </p:sp>
+      <p:sp>
+        <p:nvSpPr>
+          <p:cNvPr id="1026" name="s"/>
+          <p:cNvSpPr/>
+          <p:nvPr/>
+        </p:nvSpPr>
+        <p:spPr>
+          <a:xfrm>
+            <a:off x="4251960" y="5029200"/>
+            <a:ext cx="3703320" cy="1554480"/>
+          </a:xfrm>
+          <a:prstGeom prst="roundRect">
+            <a:avLst>
+              <a:gd name="adj" fmla="val 6000"/>
+            </a:avLst>
+          </a:prstGeom>
+          <a:solidFill>
+            <a:srgbClr val="0B1739"/>
+          </a:solidFill>
+          <a:ln>
+            <a:noFill/>
+          </a:ln>
+          <a:effectLst>
+            <a:outerShdw blurRad="50800" dist="38100" dir="2700000" rotWithShape="0">
+              <a:srgbClr val="000000">
+                <a:alpha val="35000"/>
+              </a:srgbClr>
+            </a:outerShdw>
+          </a:effectLst>
+        </p:spPr>
+        <p:txBody>
+          <a:bodyPr wrap="square" anchor="ctr" rtlCol="0" lIns="91440" tIns="91440" rIns="91440" bIns="91440"/>
+          <a:lstStyle/>
+          <a:p/>
+        </p:txBody>
+      </p:sp>
+      <p:sp>
+        <p:nvSpPr>
+          <p:cNvPr id="1027" name="r"/>
+          <p:cNvSpPr/>
+          <p:nvPr/>
+        </p:nvSpPr>
+        <p:spPr>
+          <a:xfrm>
+            <a:off x="4251960" y="5029200"/>
+            <a:ext cx="3703320" cy="54864"/>
+          </a:xfrm>
+          <a:prstGeom prst="rect">
+            <a:avLst/>
+          </a:prstGeom>
+          <a:solidFill>
+            <a:srgbClr val="F97316"/>
+          </a:solidFill>
+          <a:ln>
+            <a:noFill/>
+          </a:ln>
+        </p:spPr>
+        <p:txBody>
+          <a:bodyPr/>
+          <a:lstStyle/>
+          <a:p/>
+        </p:txBody>
+      </p:sp>
+      <p:sp>
+        <p:nvSpPr>
+          <p:cNvPr id="1028" name="t"/>
+          <p:cNvSpPr txBox="1"/>
+          <p:nvPr/>
+        </p:nvSpPr>
+        <p:spPr>
+          <a:xfrm>
+            <a:off x="4389120" y="5120640"/>
+            <a:ext cx="3657600" cy="274320"/>
+          </a:xfrm>
+          <a:prstGeom prst="rect">
+            <a:avLst/>
+          </a:prstGeom>
+          <a:noFill/>
+        </p:spPr>
+        <p:txBody>
+          <a:bodyPr wrap="square" anchor="t" rtlCol="0"/>
+          <a:lstStyle/>
+          <a:p>
+            <a:pPr algn="l">
+              <a:buNone/>
+            </a:pPr>
+            <a:r>
+              <a:rPr lang="en-US" sz="1100" b="1" dirty="0">
+                <a:solidFill>
+                  <a:srgbClr val="F97316"/>
+                </a:solidFill>
+                <a:latin typeface="Calibri"/>
+              </a:rPr>
+              <a:t>[*]  CORE ALGORITHMS</a:t>
+            </a:r>
+          </a:p>
+        </p:txBody>
+      </p:sp>
+      <p:sp>
+        <p:nvSpPr>
+          <p:cNvPr id="1029" name="t"/>
+          <p:cNvSpPr txBox="1"/>
+          <p:nvPr/>
+        </p:nvSpPr>
+        <p:spPr>
+          <a:xfrm>
+            <a:off x="4389120" y="5440680"/>
+            <a:ext cx="1463040" cy="201168"/>
+          </a:xfrm>
+          <a:prstGeom prst="rect">
+            <a:avLst/>
+          </a:prstGeom>
+          <a:noFill/>
+        </p:spPr>
+        <p:txBody>
+          <a:bodyPr wrap="square" anchor="t" rtlCol="0"/>
+          <a:lstStyle/>
+          <a:p>
+            <a:pPr algn="l">
+              <a:buNone/>
+            </a:pPr>
+            <a:r>
+              <a:rPr lang="en-US" sz="800" b="1" dirty="0">
+                <a:solidFill>
+                  <a:srgbClr val="F97316"/>
+                </a:solidFill>
+                <a:latin typeface="Calibri"/>
+              </a:rPr>
+              <a:t>K-Means++</a:t>
+            </a:r>
+          </a:p>
+        </p:txBody>
+      </p:sp>
+      <p:sp>
+        <p:nvSpPr>
+          <p:cNvPr id="1030" name="t"/>
+          <p:cNvSpPr txBox="1"/>
+          <p:nvPr/>
+        </p:nvSpPr>
+        <p:spPr>
+          <a:xfrm>
+            <a:off x="5852160" y="5440680"/>
+            <a:ext cx="2011680" cy="201168"/>
+          </a:xfrm>
+          <a:prstGeom prst="rect">
+            <a:avLst/>
+          </a:prstGeom>
+          <a:noFill/>
+        </p:spPr>
+        <p:txBody>
+          <a:bodyPr wrap="square" anchor="t" rtlCol="0"/>
+          <a:lstStyle/>
+          <a:p>
+            <a:pPr algn="l">
+              <a:buNone/>
+            </a:pPr>
+            <a:r>
+              <a:rPr lang="en-US" sz="800" dirty="0">
+                <a:solidFill>
+                  <a:srgbClr val="C8D2E0"/>
+                </a:solidFill>
+                <a:latin typeface="Calibri"/>
+              </a:rPr>
+              <a:t>Order clustering by GPS</a:t>
+            </a:r>
+          </a:p>
+        </p:txBody>
+      </p:sp>
+      <p:sp>
+        <p:nvSpPr>
+          <p:cNvPr id="1031" name="t"/>
+          <p:cNvSpPr txBox="1"/>
+          <p:nvPr/>
+        </p:nvSpPr>
+        <p:spPr>
+          <a:xfrm>
+            <a:off x="4389120" y="5660136"/>
+            <a:ext cx="1463040" cy="201168"/>
+          </a:xfrm>
+          <a:prstGeom prst="rect">
+            <a:avLst/>
+          </a:prstGeom>
+          <a:noFill/>
+        </p:spPr>
+        <p:txBody>
+          <a:bodyPr wrap="square" anchor="t" rtlCol="0"/>
+          <a:lstStyle/>
+          <a:p>
+            <a:pPr algn="l">
+              <a:buNone/>
+            </a:pPr>
+            <a:r>
+              <a:rPr lang="en-US" sz="800" b="1" dirty="0">
+                <a:solidFill>
+                  <a:srgbClr val="F97316"/>
+                </a:solidFill>
+                <a:latin typeface="Calibri"/>
+              </a:rPr>
+              <a:t>Greedy Nearest</a:t>
+            </a:r>
+          </a:p>
+        </p:txBody>
+      </p:sp>
+      <p:sp>
+        <p:nvSpPr>
+          <p:cNvPr id="1032" name="t"/>
+          <p:cNvSpPr txBox="1"/>
+          <p:nvPr/>
+        </p:nvSpPr>
+        <p:spPr>
+          <a:xfrm>
+            <a:off x="5852160" y="5660136"/>
+            <a:ext cx="2011680" cy="201168"/>
+          </a:xfrm>
+          <a:prstGeom prst="rect">
+            <a:avLst/>
+          </a:prstGeom>
+          <a:noFill/>
+        </p:spPr>
+        <p:txBody>
+          <a:bodyPr wrap="square" anchor="t" rtlCol="0"/>
+          <a:lstStyle/>
+          <a:p>
+            <a:pPr algn="l">
+              <a:buNone/>
+            </a:pPr>
+            <a:r>
+              <a:rPr lang="en-US" sz="800" dirty="0">
+                <a:solidFill>
+                  <a:srgbClr val="C8D2E0"/>
+                </a:solidFill>
+                <a:latin typeface="Calibri"/>
+              </a:rPr>
+              <a:t>Agent &lt;-&gt; cluster pairing</a:t>
+            </a:r>
+          </a:p>
+        </p:txBody>
+      </p:sp>
+      <p:sp>
+        <p:nvSpPr>
+          <p:cNvPr id="1033" name="t"/>
+          <p:cNvSpPr txBox="1"/>
+          <p:nvPr/>
+        </p:nvSpPr>
+        <p:spPr>
+          <a:xfrm>
+            <a:off x="4389120" y="5879592"/>
+            <a:ext cx="1463040" cy="201168"/>
+          </a:xfrm>
+          <a:prstGeom prst="rect">
+            <a:avLst/>
+          </a:prstGeom>
+          <a:noFill/>
+        </p:spPr>
+        <p:txBody>
+          <a:bodyPr wrap="square" anchor="t" rtlCol="0"/>
+          <a:lstStyle/>
+          <a:p>
+            <a:pPr algn="l">
+              <a:buNone/>
+            </a:pPr>
+            <a:r>
+              <a:rPr lang="en-US" sz="800" b="1" dirty="0">
+                <a:solidFill>
+                  <a:srgbClr val="F97316"/>
+                </a:solidFill>
+                <a:latin typeface="Calibri"/>
+              </a:rPr>
+              <a:t>Priority-Weighted</a:t>
+            </a:r>
+          </a:p>
+        </p:txBody>
+      </p:sp>
+      <p:sp>
+        <p:nvSpPr>
+          <p:cNvPr id="1034" name="t"/>
+          <p:cNvSpPr txBox="1"/>
+          <p:nvPr/>
+        </p:nvSpPr>
+        <p:spPr>
+          <a:xfrm>
+            <a:off x="5852160" y="5879592"/>
+            <a:ext cx="2011680" cy="201168"/>
+          </a:xfrm>
+          <a:prstGeom prst="rect">
+            <a:avLst/>
+          </a:prstGeom>
+          <a:noFill/>
+        </p:spPr>
+        <p:txBody>
+          <a:bodyPr wrap="square" anchor="t" rtlCol="0"/>
+          <a:lstStyle/>
+          <a:p>
+            <a:pPr algn="l">
+              <a:buNone/>
+            </a:pPr>
+            <a:r>
+              <a:rPr lang="en-US" sz="800" dirty="0">
+                <a:solidFill>
+                  <a:srgbClr val="C8D2E0"/>
+                </a:solidFill>
+                <a:latin typeface="Calibri"/>
+              </a:rPr>
+              <a:t>Route sequencing</a:t>
+            </a:r>
+          </a:p>
+        </p:txBody>
+      </p:sp>
+      <p:sp>
+        <p:nvSpPr>
+          <p:cNvPr id="1035" name="t"/>
+          <p:cNvSpPr txBox="1"/>
+          <p:nvPr/>
+        </p:nvSpPr>
+        <p:spPr>
+          <a:xfrm>
+            <a:off x="4389120" y="6099048"/>
+            <a:ext cx="1463040" cy="201168"/>
+          </a:xfrm>
+          <a:prstGeom prst="rect">
+            <a:avLst/>
+          </a:prstGeom>
+          <a:noFill/>
+        </p:spPr>
+        <p:txBody>
+          <a:bodyPr wrap="square" anchor="t" rtlCol="0"/>
+          <a:lstStyle/>
+          <a:p>
+            <a:pPr algn="l">
+              <a:buNone/>
+            </a:pPr>
+            <a:r>
+              <a:rPr lang="en-US" sz="800" b="1" dirty="0">
+                <a:solidFill>
+                  <a:srgbClr val="F97316"/>
+                </a:solidFill>
+                <a:latin typeface="Calibri"/>
+              </a:rPr>
+              <a:t>Heuristic P-Score</a:t>
+            </a:r>
+          </a:p>
+        </p:txBody>
+      </p:sp>
+      <p:sp>
+        <p:nvSpPr>
+          <p:cNvPr id="1036" name="t"/>
+          <p:cNvSpPr txBox="1"/>
+          <p:nvPr/>
+        </p:nvSpPr>
+        <p:spPr>
+          <a:xfrm>
+            <a:off x="5852160" y="6099048"/>
+            <a:ext cx="2011680" cy="201168"/>
+          </a:xfrm>
+          <a:prstGeom prst="rect">
+            <a:avLst/>
+          </a:prstGeom>
+          <a:noFill/>
+        </p:spPr>
+        <p:txBody>
+          <a:bodyPr wrap="square" anchor="t" rtlCol="0"/>
+          <a:lstStyle/>
+          <a:p>
+            <a:pPr algn="l">
+              <a:buNone/>
+            </a:pPr>
+            <a:r>
+              <a:rPr lang="en-US" sz="800" dirty="0">
+                <a:solidFill>
+                  <a:srgbClr val="C8D2E0"/>
+                </a:solidFill>
+                <a:latin typeface="Calibri"/>
+              </a:rPr>
+              <a:t>Crisis-mode allocation</a:t>
+            </a:r>
+          </a:p>
+        </p:txBody>
+      </p:sp>
+      <p:sp>
+        <p:nvSpPr>
+          <p:cNvPr id="1037" name="t"/>
+          <p:cNvSpPr txBox="1"/>
+          <p:nvPr/>
+        </p:nvSpPr>
+        <p:spPr>
+          <a:xfrm>
+            <a:off x="4389120" y="6318504"/>
+            <a:ext cx="1463040" cy="201168"/>
+          </a:xfrm>
+          <a:prstGeom prst="rect">
+            <a:avLst/>
+          </a:prstGeom>
+          <a:noFill/>
+        </p:spPr>
+        <p:txBody>
+          <a:bodyPr wrap="square" anchor="t" rtlCol="0"/>
+          <a:lstStyle/>
+          <a:p>
+            <a:pPr algn="l">
+              <a:buNone/>
+            </a:pPr>
+            <a:r>
+              <a:rPr lang="en-US" sz="800" b="1" dirty="0">
+                <a:solidFill>
+                  <a:srgbClr val="F97316"/>
+                </a:solidFill>
+                <a:latin typeface="Calibri"/>
+              </a:rPr>
+              <a:t>Max-Heap Ranking</a:t>
+            </a:r>
+          </a:p>
+        </p:txBody>
+      </p:sp>
+      <p:sp>
+        <p:nvSpPr>
+          <p:cNvPr id="1038" name="t"/>
+          <p:cNvSpPr txBox="1"/>
+          <p:nvPr/>
+        </p:nvSpPr>
+        <p:spPr>
+          <a:xfrm>
+            <a:off x="5852160" y="6318504"/>
+            <a:ext cx="2011680" cy="201168"/>
+          </a:xfrm>
+          <a:prstGeom prst="rect">
+            <a:avLst/>
+          </a:prstGeom>
+          <a:noFill/>
+        </p:spPr>
+        <p:txBody>
+          <a:bodyPr wrap="square" anchor="t" rtlCol="0"/>
+          <a:lstStyle/>
+          <a:p>
+            <a:pPr algn="l">
+              <a:buNone/>
+            </a:pPr>
+            <a:r>
+              <a:rPr lang="en-US" sz="800" dirty="0">
+                <a:solidFill>
+                  <a:srgbClr val="C8D2E0"/>
+                </a:solidFill>
+                <a:latin typeface="Calibri"/>
+              </a:rPr>
+              <a:t>Descending P order</a:t>
+            </a:r>
+          </a:p>
+        </p:txBody>
+      </p:sp>
+      <p:sp>
+        <p:nvSpPr>
+          <p:cNvPr id="1039" name="s"/>
+          <p:cNvSpPr/>
+          <p:nvPr/>
+        </p:nvSpPr>
+        <p:spPr>
+          <a:xfrm>
+            <a:off x="8138160" y="5029200"/>
+            <a:ext cx="3657600" cy="1554480"/>
+          </a:xfrm>
+          <a:prstGeom prst="roundRect">
+            <a:avLst>
+              <a:gd name="adj" fmla="val 6000"/>
+            </a:avLst>
+          </a:prstGeom>
+          <a:solidFill>
+            <a:srgbClr val="17264C"/>
+          </a:solidFill>
+          <a:ln>
+            <a:noFill/>
+          </a:ln>
+          <a:effectLst>
+            <a:outerShdw blurRad="50800" dist="38100" dir="2700000" rotWithShape="0">
+              <a:srgbClr val="000000">
+                <a:alpha val="35000"/>
+              </a:srgbClr>
+            </a:outerShdw>
+          </a:effectLst>
+        </p:spPr>
+        <p:txBody>
+          <a:bodyPr wrap="square" anchor="ctr" rtlCol="0" lIns="91440" tIns="91440" rIns="91440" bIns="91440"/>
+          <a:lstStyle/>
+          <a:p/>
+        </p:txBody>
+      </p:sp>
+      <p:sp>
+        <p:nvSpPr>
+          <p:cNvPr id="1040" name="r"/>
+          <p:cNvSpPr/>
+          <p:nvPr/>
+        </p:nvSpPr>
+        <p:spPr>
+          <a:xfrm>
+            <a:off x="8138160" y="5029200"/>
+            <a:ext cx="3657600" cy="54864"/>
+          </a:xfrm>
+          <a:prstGeom prst="rect">
+            <a:avLst/>
+          </a:prstGeom>
+          <a:solidFill>
+            <a:srgbClr val="10B981"/>
+          </a:solidFill>
+          <a:ln>
+            <a:noFill/>
+          </a:ln>
+        </p:spPr>
+        <p:txBody>
+          <a:bodyPr/>
+          <a:lstStyle/>
+          <a:p/>
+        </p:txBody>
+      </p:sp>
+      <p:sp>
+        <p:nvSpPr>
+          <p:cNvPr id="1041" name="t"/>
+          <p:cNvSpPr txBox="1"/>
+          <p:nvPr/>
+        </p:nvSpPr>
+        <p:spPr>
+          <a:xfrm>
+            <a:off x="8275320" y="5120640"/>
+            <a:ext cx="3657600" cy="274320"/>
+          </a:xfrm>
+          <a:prstGeom prst="rect">
+            <a:avLst/>
+          </a:prstGeom>
+          <a:noFill/>
+        </p:spPr>
+        <p:txBody>
+          <a:bodyPr wrap="square" anchor="t" rtlCol="0"/>
+          <a:lstStyle/>
+          <a:p>
+            <a:pPr algn="l">
+              <a:buNone/>
+            </a:pPr>
+            <a:r>
+              <a:rPr lang="en-US" sz="1100" b="1" dirty="0">
+                <a:solidFill>
+                  <a:srgbClr val="10B981"/>
+                </a:solidFill>
+                <a:latin typeface="Calibri"/>
+              </a:rPr>
+              <a:t>[*]  ORDER LIFECYCLE</a:t>
+            </a:r>
+          </a:p>
+        </p:txBody>
+      </p:sp>
+      <p:sp>
+        <p:nvSpPr>
+          <p:cNvPr id="1042" name="c"/>
+          <p:cNvSpPr/>
+          <p:nvPr/>
+        </p:nvSpPr>
+        <p:spPr>
+          <a:xfrm>
+            <a:off x="8321040" y="5440680"/>
+            <a:ext cx="201168" cy="201168"/>
+          </a:xfrm>
+          <a:prstGeom prst="ellipse">
+            <a:avLst/>
+          </a:prstGeom>
+          <a:solidFill>
+            <a:srgbClr val="3B82F6"/>
+          </a:solidFill>
+          <a:ln>
+            <a:noFill/>
+          </a:ln>
+        </p:spPr>
+        <p:txBody>
+          <a:bodyPr/>
+          <a:lstStyle/>
+          <a:p/>
+        </p:txBody>
+      </p:sp>
+      <p:sp>
+        <p:nvSpPr>
+          <p:cNvPr id="1043" name="t"/>
+          <p:cNvSpPr txBox="1"/>
+          <p:nvPr/>
+        </p:nvSpPr>
+        <p:spPr>
+          <a:xfrm>
+            <a:off x="8321040" y="5468112"/>
+            <a:ext cx="201168" cy="201168"/>
+          </a:xfrm>
+          <a:prstGeom prst="rect">
+            <a:avLst/>
+          </a:prstGeom>
+          <a:noFill/>
+        </p:spPr>
+        <p:txBody>
+          <a:bodyPr wrap="square" anchor="t" rtlCol="0"/>
+          <a:lstStyle/>
+          <a:p>
+            <a:pPr algn="ctr">
+              <a:buNone/>
+            </a:pPr>
+            <a:r>
+              <a:rPr lang="en-US" sz="900" b="1" dirty="0">
+                <a:solidFill>
+                  <a:srgbClr val="FFFFFF"/>
+                </a:solidFill>
+                <a:latin typeface="Calibri"/>
+              </a:rPr>
+              <a:t>1</a:t>
+            </a:r>
+          </a:p>
+        </p:txBody>
+      </p:sp>
+      <p:sp>
+        <p:nvSpPr>
+          <p:cNvPr id="1044" name="t"/>
+          <p:cNvSpPr txBox="1"/>
+          <p:nvPr/>
+        </p:nvSpPr>
+        <p:spPr>
+          <a:xfrm>
+            <a:off x="8641080" y="5468112"/>
+            <a:ext cx="2286000" cy="201168"/>
+          </a:xfrm>
+          <a:prstGeom prst="rect">
+            <a:avLst/>
+          </a:prstGeom>
+          <a:noFill/>
+        </p:spPr>
+        <p:txBody>
+          <a:bodyPr wrap="square" anchor="t" rtlCol="0"/>
+          <a:lstStyle/>
+          <a:p>
+            <a:pPr algn="l">
+              <a:buNone/>
+            </a:pPr>
+            <a:r>
+              <a:rPr lang="en-US" sz="900" b="1" dirty="0">
+                <a:solidFill>
+                  <a:srgbClr val="FFFFFF"/>
+                </a:solidFill>
+                <a:latin typeface="Calibri"/>
+              </a:rPr>
+              <a:t>CREATED</a:t>
+            </a:r>
+          </a:p>
+        </p:txBody>
+      </p:sp>
+      <p:cxnSp>
+        <p:nvCxnSpPr>
+          <p:cNvPr id="1045" name="ln"/>
+          <p:cNvCxnSpPr/>
+          <p:nvPr/>
+        </p:nvCxnSpPr>
+        <p:spPr>
+          <a:xfrm flipH="0" flipV="0">
+            <a:off x="8421624" y="5641848"/>
+            <a:ext cx="1" cy="73152"/>
+          </a:xfrm>
+          <a:prstGeom prst="line">
+            <a:avLst/>
+          </a:prstGeom>
+          <a:ln w="15000">
+            <a:solidFill>
+              <a:srgbClr val="3B82F6"/>
+            </a:solidFill>
+          </a:ln>
+        </p:spPr>
+      </p:cxnSp>
+      <p:sp>
+        <p:nvSpPr>
+          <p:cNvPr id="1046" name="c"/>
+          <p:cNvSpPr/>
+          <p:nvPr/>
+        </p:nvSpPr>
+        <p:spPr>
+          <a:xfrm>
+            <a:off x="8321040" y="5715000"/>
+            <a:ext cx="201168" cy="201168"/>
+          </a:xfrm>
+          <a:prstGeom prst="ellipse">
+            <a:avLst/>
+          </a:prstGeom>
+          <a:solidFill>
+            <a:srgbClr val="F97316"/>
+          </a:solidFill>
+          <a:ln>
+            <a:noFill/>
+          </a:ln>
+        </p:spPr>
+        <p:txBody>
+          <a:bodyPr/>
+          <a:lstStyle/>
+          <a:p/>
+        </p:txBody>
+      </p:sp>
+      <p:sp>
+        <p:nvSpPr>
+          <p:cNvPr id="1047" name="t"/>
+          <p:cNvSpPr txBox="1"/>
+          <p:nvPr/>
+        </p:nvSpPr>
+        <p:spPr>
+          <a:xfrm>
+            <a:off x="8321040" y="5742432"/>
+            <a:ext cx="201168" cy="201168"/>
+          </a:xfrm>
+          <a:prstGeom prst="rect">
+            <a:avLst/>
+          </a:prstGeom>
+          <a:noFill/>
+        </p:spPr>
+        <p:txBody>
+          <a:bodyPr wrap="square" anchor="t" rtlCol="0"/>
+          <a:lstStyle/>
+          <a:p>
+            <a:pPr algn="ctr">
+              <a:buNone/>
+            </a:pPr>
+            <a:r>
+              <a:rPr lang="en-US" sz="900" b="1" dirty="0">
+                <a:solidFill>
+                  <a:srgbClr val="FFFFFF"/>
+                </a:solidFill>
+                <a:latin typeface="Calibri"/>
+              </a:rPr>
+              <a:t>2</a:t>
+            </a:r>
+          </a:p>
+        </p:txBody>
+      </p:sp>
+      <p:sp>
+        <p:nvSpPr>
+          <p:cNvPr id="1048" name="t"/>
+          <p:cNvSpPr txBox="1"/>
+          <p:nvPr/>
+        </p:nvSpPr>
+        <p:spPr>
+          <a:xfrm>
+            <a:off x="8641080" y="5742432"/>
+            <a:ext cx="2286000" cy="201168"/>
+          </a:xfrm>
+          <a:prstGeom prst="rect">
+            <a:avLst/>
+          </a:prstGeom>
+          <a:noFill/>
+        </p:spPr>
+        <p:txBody>
+          <a:bodyPr wrap="square" anchor="t" rtlCol="0"/>
+          <a:lstStyle/>
+          <a:p>
+            <a:pPr algn="l">
+              <a:buNone/>
+            </a:pPr>
+            <a:r>
+              <a:rPr lang="en-US" sz="900" b="1" dirty="0">
+                <a:solidFill>
+                  <a:srgbClr val="FFFFFF"/>
+                </a:solidFill>
+                <a:latin typeface="Calibri"/>
+              </a:rPr>
+              <a:t>ASSIGNED</a:t>
+            </a:r>
+          </a:p>
+        </p:txBody>
+      </p:sp>
+      <p:cxnSp>
+        <p:nvCxnSpPr>
+          <p:cNvPr id="1049" name="ln"/>
+          <p:cNvCxnSpPr/>
+          <p:nvPr/>
+        </p:nvCxnSpPr>
+        <p:spPr>
+          <a:xfrm flipH="0" flipV="0">
+            <a:off x="8421624" y="5916168"/>
+            <a:ext cx="1" cy="73152"/>
+          </a:xfrm>
+          <a:prstGeom prst="line">
+            <a:avLst/>
+          </a:prstGeom>
+          <a:ln w="15000">
+            <a:solidFill>
+              <a:srgbClr val="F97316"/>
+            </a:solidFill>
+          </a:ln>
+        </p:spPr>
+      </p:cxnSp>
+      <p:sp>
+        <p:nvSpPr>
+          <p:cNvPr id="1050" name="c"/>
+          <p:cNvSpPr/>
+          <p:nvPr/>
+        </p:nvSpPr>
+        <p:spPr>
+          <a:xfrm>
+            <a:off x="8321040" y="5989320"/>
+            <a:ext cx="201168" cy="201168"/>
+          </a:xfrm>
+          <a:prstGeom prst="ellipse">
+            <a:avLst/>
+          </a:prstGeom>
+          <a:solidFill>
+            <a:srgbClr val="8B5CF6"/>
+          </a:solidFill>
+          <a:ln>
+            <a:noFill/>
+          </a:ln>
+        </p:spPr>
+        <p:txBody>
+          <a:bodyPr/>
+          <a:lstStyle/>
+          <a:p/>
+        </p:txBody>
+      </p:sp>
+      <p:sp>
+        <p:nvSpPr>
+          <p:cNvPr id="1051" name="t"/>
+          <p:cNvSpPr txBox="1"/>
+          <p:nvPr/>
+        </p:nvSpPr>
+        <p:spPr>
+          <a:xfrm>
+            <a:off x="8321040" y="6016752"/>
+            <a:ext cx="201168" cy="201168"/>
+          </a:xfrm>
+          <a:prstGeom prst="rect">
+            <a:avLst/>
+          </a:prstGeom>
+          <a:noFill/>
+        </p:spPr>
+        <p:txBody>
+          <a:bodyPr wrap="square" anchor="t" rtlCol="0"/>
+          <a:lstStyle/>
+          <a:p>
+            <a:pPr algn="ctr">
+              <a:buNone/>
+            </a:pPr>
+            <a:r>
+              <a:rPr lang="en-US" sz="900" b="1" dirty="0">
+                <a:solidFill>
+                  <a:srgbClr val="FFFFFF"/>
+                </a:solidFill>
+                <a:latin typeface="Calibri"/>
+              </a:rPr>
+              <a:t>3</a:t>
+            </a:r>
+          </a:p>
+        </p:txBody>
+      </p:sp>
+      <p:sp>
+        <p:nvSpPr>
+          <p:cNvPr id="1052" name="t"/>
+          <p:cNvSpPr txBox="1"/>
+          <p:nvPr/>
+        </p:nvSpPr>
+        <p:spPr>
+          <a:xfrm>
+            <a:off x="8641080" y="6016752"/>
+            <a:ext cx="2286000" cy="201168"/>
+          </a:xfrm>
+          <a:prstGeom prst="rect">
+            <a:avLst/>
+          </a:prstGeom>
+          <a:noFill/>
+        </p:spPr>
+        <p:txBody>
+          <a:bodyPr wrap="square" anchor="t" rtlCol="0"/>
+          <a:lstStyle/>
+          <a:p>
+            <a:pPr algn="l">
+              <a:buNone/>
+            </a:pPr>
+            <a:r>
+              <a:rPr lang="en-US" sz="900" b="1" dirty="0">
+                <a:solidFill>
+                  <a:srgbClr val="FFFFFF"/>
+                </a:solidFill>
+                <a:latin typeface="Calibri"/>
+              </a:rPr>
+              <a:t>OUT FOR DELIVERY</a:t>
+            </a:r>
+          </a:p>
+        </p:txBody>
+      </p:sp>
+      <p:cxnSp>
+        <p:nvCxnSpPr>
+          <p:cNvPr id="1053" name="ln"/>
+          <p:cNvCxnSpPr/>
+          <p:nvPr/>
+        </p:nvCxnSpPr>
+        <p:spPr>
+          <a:xfrm flipH="0" flipV="0">
+            <a:off x="8421624" y="6190488"/>
+            <a:ext cx="1" cy="73152"/>
+          </a:xfrm>
+          <a:prstGeom prst="line">
+            <a:avLst/>
+          </a:prstGeom>
+          <a:ln w="15000">
+            <a:solidFill>
+              <a:srgbClr val="8B5CF6"/>
+            </a:solidFill>
+          </a:ln>
+        </p:spPr>
+      </p:cxnSp>
+      <p:sp>
+        <p:nvSpPr>
+          <p:cNvPr id="1054" name="c"/>
+          <p:cNvSpPr/>
+          <p:nvPr/>
+        </p:nvSpPr>
+        <p:spPr>
+          <a:xfrm>
+            <a:off x="8321040" y="6263640"/>
+            <a:ext cx="201168" cy="201168"/>
+          </a:xfrm>
+          <a:prstGeom prst="ellipse">
+            <a:avLst/>
+          </a:prstGeom>
+          <a:solidFill>
+            <a:srgbClr val="10B981"/>
+          </a:solidFill>
+          <a:ln>
+            <a:noFill/>
+          </a:ln>
+        </p:spPr>
+        <p:txBody>
+          <a:bodyPr/>
+          <a:lstStyle/>
+          <a:p/>
+        </p:txBody>
+      </p:sp>
+      <p:sp>
+        <p:nvSpPr>
+          <p:cNvPr id="1055" name="t"/>
+          <p:cNvSpPr txBox="1"/>
+          <p:nvPr/>
+        </p:nvSpPr>
+        <p:spPr>
+          <a:xfrm>
+            <a:off x="8321040" y="6291072"/>
+            <a:ext cx="201168" cy="201168"/>
+          </a:xfrm>
+          <a:prstGeom prst="rect">
+            <a:avLst/>
+          </a:prstGeom>
+          <a:noFill/>
+        </p:spPr>
+        <p:txBody>
+          <a:bodyPr wrap="square" anchor="t" rtlCol="0"/>
+          <a:lstStyle/>
+          <a:p>
+            <a:pPr algn="ctr">
+              <a:buNone/>
+            </a:pPr>
+            <a:r>
+              <a:rPr lang="en-US" sz="900" b="1" dirty="0">
+                <a:solidFill>
+                  <a:srgbClr val="FFFFFF"/>
+                </a:solidFill>
+                <a:latin typeface="Calibri"/>
+              </a:rPr>
+              <a:t>4</a:t>
+            </a:r>
+          </a:p>
+        </p:txBody>
+      </p:sp>
+      <p:sp>
+        <p:nvSpPr>
+          <p:cNvPr id="1056" name="t"/>
+          <p:cNvSpPr txBox="1"/>
+          <p:nvPr/>
+        </p:nvSpPr>
+        <p:spPr>
+          <a:xfrm>
+            <a:off x="8641080" y="6291072"/>
+            <a:ext cx="2286000" cy="201168"/>
+          </a:xfrm>
+          <a:prstGeom prst="rect">
+            <a:avLst/>
+          </a:prstGeom>
+          <a:noFill/>
+        </p:spPr>
+        <p:txBody>
+          <a:bodyPr wrap="square" anchor="t" rtlCol="0"/>
+          <a:lstStyle/>
+          <a:p>
+            <a:pPr algn="l">
+              <a:buNone/>
+            </a:pPr>
+            <a:r>
+              <a:rPr lang="en-US" sz="900" b="1" dirty="0">
+                <a:solidFill>
+                  <a:srgbClr val="FFFFFF"/>
+                </a:solidFill>
+                <a:latin typeface="Calibri"/>
+              </a:rPr>
+              <a:t>DELIVERED</a:t>
+            </a:r>
+          </a:p>
+        </p:txBody>
+      </p:sp>
+      <p:sp>
+        <p:nvSpPr>
+          <p:cNvPr id="1057" name="t"/>
+          <p:cNvSpPr txBox="1"/>
+          <p:nvPr/>
+        </p:nvSpPr>
+        <p:spPr>
+          <a:xfrm>
+            <a:off x="8275320" y="6400800"/>
+            <a:ext cx="3474720" cy="164592"/>
+          </a:xfrm>
+          <a:prstGeom prst="rect">
+            <a:avLst/>
+          </a:prstGeom>
+          <a:noFill/>
+        </p:spPr>
+        <p:txBody>
+          <a:bodyPr wrap="square" anchor="t" rtlCol="0"/>
+          <a:lstStyle/>
+          <a:p>
+            <a:pPr algn="l">
+              <a:buNone/>
+            </a:pPr>
+            <a:r>
+              <a:rPr lang="en-US" sz="700" b="1" dirty="0">
+                <a:solidFill>
+                  <a:srgbClr val="FBBF24"/>
+                </a:solidFill>
+                <a:latin typeface="Calibri"/>
+              </a:rPr>
+              <a:t>OTP + Photo proof verification at delivery</a:t>
+            </a:r>
+          </a:p>
+        </p:txBody>
+      </p:sp>
+      <p:sp>
+        <p:nvSpPr>
+          <p:cNvPr id="1058" name="t"/>
+          <p:cNvSpPr txBox="1"/>
+          <p:nvPr/>
+        </p:nvSpPr>
+        <p:spPr>
+          <a:xfrm>
+            <a:off x="365760" y="6629400"/>
+            <a:ext cx="10058400" cy="182880"/>
+          </a:xfrm>
+          <a:prstGeom prst="rect">
+            <a:avLst/>
+          </a:prstGeom>
+          <a:noFill/>
+        </p:spPr>
+        <p:txBody>
+          <a:bodyPr wrap="square" anchor="t" rtlCol="0"/>
+          <a:lstStyle/>
+          <a:p>
+            <a:pPr algn="l">
+              <a:buNone/>
+            </a:pPr>
+            <a:r>
+              <a:rPr lang="en-US" sz="800" b="1" dirty="0">
+                <a:solidFill>
+                  <a:srgbClr val="94A3B8"/>
+                </a:solidFill>
+                <a:latin typeface="Calibri"/>
+              </a:rPr>
+              <a:t>Production-grade backend  -  Docker + K8s ready  -  REST + WebSocket  -  Multi-database (MongoDB + Redis)</a:t>
+            </a:r>
+          </a:p>
+        </p:txBody>
+      </p:sp>
+      <p:sp>
+        <p:nvSpPr>
+          <p:cNvPr id="1059" name="t"/>
+          <p:cNvSpPr txBox="1"/>
+          <p:nvPr/>
+        </p:nvSpPr>
+        <p:spPr>
+          <a:xfrm>
+            <a:off x="11521440" y="6629400"/>
+            <a:ext cx="457200" cy="182880"/>
+          </a:xfrm>
+          <a:prstGeom prst="rect">
+            <a:avLst/>
+          </a:prstGeom>
+          <a:noFill/>
+        </p:spPr>
+        <p:txBody>
+          <a:bodyPr wrap="square" anchor="t" rtlCol="0"/>
+          <a:lstStyle/>
+          <a:p>
+            <a:pPr algn="r">
+              <a:buNone/>
+            </a:pPr>
+            <a:r>
+              <a:rPr lang="en-US" sz="1200" b="1" dirty="0">
+                <a:solidFill>
+                  <a:srgbClr val="94A3B8"/>
+                </a:solidFill>
+                <a:latin typeface="Calibri"/>
+              </a:rPr>
+              <a:t>12</a:t>
+            </a:r>
+          </a:p>
+        </p:txBody>
+      </p:sp>
+    </p:spTree>
+  </p:cSld>
+  <p:transition spd="med">
+    <p:split orient="horz" dir="out"/>
+  </p:transition>
+  <p:clrMapOvr>
+    <a:masterClrMapping/>
+  </p:clrMapOvr>
+</p:sld>
+</file>
+
 <file path=ppt/slides/slide2.xml><?xml version="1.0" encoding="utf-8"?>
 <p:sld xmlns:a="http://schemas.openxmlformats.org/drawingml/2006/main" xmlns:r="http://schemas.openxmlformats.org/officeDocument/2006/relationships" xmlns:p="http://schemas.openxmlformats.org/presentationml/2006/main">
   <p:cSld>

</xml_diff>